<commit_message>
Update presentation files and replace old ROC/AUC visualizations with enhanced versions
</commit_message>
<xml_diff>
--- a/PPTX_CSV_Files/H1N1_Vaccine_Predictive_Presentation_Abel_Aleu_Chol.pptx
+++ b/PPTX_CSV_Files/H1N1_Vaccine_Predictive_Presentation_Abel_Aleu_Chol.pptx
@@ -5,27 +5,29 @@
     <p:sldMasterId id="2147483714" r:id="rId1"/>
   </p:sldMasterIdLst>
   <p:notesMasterIdLst>
-    <p:notesMasterId r:id="rId20"/>
+    <p:notesMasterId r:id="rId22"/>
   </p:notesMasterIdLst>
   <p:sldIdLst>
     <p:sldId id="271" r:id="rId2"/>
     <p:sldId id="272" r:id="rId3"/>
-    <p:sldId id="286" r:id="rId4"/>
-    <p:sldId id="273" r:id="rId5"/>
-    <p:sldId id="282" r:id="rId6"/>
-    <p:sldId id="283" r:id="rId7"/>
-    <p:sldId id="274" r:id="rId8"/>
-    <p:sldId id="275" r:id="rId9"/>
-    <p:sldId id="285" r:id="rId10"/>
-    <p:sldId id="276" r:id="rId11"/>
-    <p:sldId id="284" r:id="rId12"/>
-    <p:sldId id="277" r:id="rId13"/>
-    <p:sldId id="288" r:id="rId14"/>
-    <p:sldId id="278" r:id="rId15"/>
-    <p:sldId id="287" r:id="rId16"/>
-    <p:sldId id="279" r:id="rId17"/>
-    <p:sldId id="280" r:id="rId18"/>
-    <p:sldId id="281" r:id="rId19"/>
+    <p:sldId id="289" r:id="rId4"/>
+    <p:sldId id="290" r:id="rId5"/>
+    <p:sldId id="286" r:id="rId6"/>
+    <p:sldId id="273" r:id="rId7"/>
+    <p:sldId id="282" r:id="rId8"/>
+    <p:sldId id="283" r:id="rId9"/>
+    <p:sldId id="274" r:id="rId10"/>
+    <p:sldId id="275" r:id="rId11"/>
+    <p:sldId id="285" r:id="rId12"/>
+    <p:sldId id="276" r:id="rId13"/>
+    <p:sldId id="284" r:id="rId14"/>
+    <p:sldId id="277" r:id="rId15"/>
+    <p:sldId id="288" r:id="rId16"/>
+    <p:sldId id="278" r:id="rId17"/>
+    <p:sldId id="287" r:id="rId18"/>
+    <p:sldId id="279" r:id="rId19"/>
+    <p:sldId id="280" r:id="rId20"/>
+    <p:sldId id="281" r:id="rId21"/>
   </p:sldIdLst>
   <p:sldSz cx="9144000" cy="6858000" type="screen4x3"/>
   <p:notesSz cx="6858000" cy="9144000"/>
@@ -387,6 +389,204 @@
         <p:cNvPr id="1" name="">
           <a:extLst>
             <a:ext uri="{FF2B5EF4-FFF2-40B4-BE49-F238E27FC236}">
+              <a16:creationId xmlns:a16="http://schemas.microsoft.com/office/drawing/2014/main" id="{0D83B98D-6582-52CE-D0A1-AF5EAC7E1EEE}"/>
+            </a:ext>
+          </a:extLst>
+        </p:cNvPr>
+        <p:cNvGrpSpPr/>
+        <p:nvPr/>
+      </p:nvGrpSpPr>
+      <p:grpSpPr>
+        <a:xfrm>
+          <a:off x="0" y="0"/>
+          <a:ext cx="0" cy="0"/>
+          <a:chOff x="0" y="0"/>
+          <a:chExt cx="0" cy="0"/>
+        </a:xfrm>
+      </p:grpSpPr>
+      <p:sp>
+        <p:nvSpPr>
+          <p:cNvPr id="2" name="Slide Image Placeholder 1">
+            <a:extLst>
+              <a:ext uri="{FF2B5EF4-FFF2-40B4-BE49-F238E27FC236}">
+                <a16:creationId xmlns:a16="http://schemas.microsoft.com/office/drawing/2014/main" id="{BA8BE577-F512-9FA4-95BD-E3809350923B}"/>
+              </a:ext>
+            </a:extLst>
+          </p:cNvPr>
+          <p:cNvSpPr>
+            <a:spLocks noGrp="1" noRot="1" noChangeAspect="1"/>
+          </p:cNvSpPr>
+          <p:nvPr>
+            <p:ph type="sldImg" idx="2"/>
+          </p:nvPr>
+        </p:nvSpPr>
+        <p:spPr/>
+      </p:sp>
+      <p:sp>
+        <p:nvSpPr>
+          <p:cNvPr id="3" name="Notes Placeholder 2">
+            <a:extLst>
+              <a:ext uri="{FF2B5EF4-FFF2-40B4-BE49-F238E27FC236}">
+                <a16:creationId xmlns:a16="http://schemas.microsoft.com/office/drawing/2014/main" id="{330DC3C9-502D-57F4-D2DB-14819BD36901}"/>
+              </a:ext>
+            </a:extLst>
+          </p:cNvPr>
+          <p:cNvSpPr>
+            <a:spLocks noGrp="1"/>
+          </p:cNvSpPr>
+          <p:nvPr>
+            <p:ph type="body" sz="quarter" idx="3"/>
+          </p:nvPr>
+        </p:nvSpPr>
+        <p:spPr/>
+        <p:txBody>
+          <a:bodyPr/>
+          <a:lstStyle/>
+          <a:p>
+            <a:r>
+              <a:t>Explain the dataset, objective, and the challenge of predicting a rare event.</a:t>
+            </a:r>
+          </a:p>
+        </p:txBody>
+      </p:sp>
+      <p:sp>
+        <p:nvSpPr>
+          <p:cNvPr id="4" name="Slide Number Placeholder 3">
+            <a:extLst>
+              <a:ext uri="{FF2B5EF4-FFF2-40B4-BE49-F238E27FC236}">
+                <a16:creationId xmlns:a16="http://schemas.microsoft.com/office/drawing/2014/main" id="{E3650BA1-C114-10DC-99A2-96319CC16A40}"/>
+              </a:ext>
+            </a:extLst>
+          </p:cNvPr>
+          <p:cNvSpPr>
+            <a:spLocks noGrp="1"/>
+          </p:cNvSpPr>
+          <p:nvPr>
+            <p:ph type="sldNum" sz="quarter" idx="5"/>
+          </p:nvPr>
+        </p:nvSpPr>
+        <p:spPr/>
+      </p:sp>
+    </p:spTree>
+    <p:extLst>
+      <p:ext uri="{BB962C8B-B14F-4D97-AF65-F5344CB8AC3E}">
+        <p14:creationId xmlns:p14="http://schemas.microsoft.com/office/powerpoint/2010/main" val="2167343352"/>
+      </p:ext>
+    </p:extLst>
+  </p:cSld>
+  <p:clrMapOvr>
+    <a:masterClrMapping/>
+  </p:clrMapOvr>
+</p:notes>
+</file>
+
+<file path=ppt/notesSlides/notesSlide11.xml><?xml version="1.0" encoding="utf-8"?>
+<p:notes xmlns:a="http://schemas.openxmlformats.org/drawingml/2006/main" xmlns:r="http://schemas.openxmlformats.org/officeDocument/2006/relationships" xmlns:p="http://schemas.openxmlformats.org/presentationml/2006/main">
+  <p:cSld>
+    <p:spTree>
+      <p:nvGrpSpPr>
+        <p:cNvPr id="1" name="">
+          <a:extLst>
+            <a:ext uri="{FF2B5EF4-FFF2-40B4-BE49-F238E27FC236}">
+              <a16:creationId xmlns:a16="http://schemas.microsoft.com/office/drawing/2014/main" id="{75831669-FC06-E49D-214F-651E93CE3444}"/>
+            </a:ext>
+          </a:extLst>
+        </p:cNvPr>
+        <p:cNvGrpSpPr/>
+        <p:nvPr/>
+      </p:nvGrpSpPr>
+      <p:grpSpPr>
+        <a:xfrm>
+          <a:off x="0" y="0"/>
+          <a:ext cx="0" cy="0"/>
+          <a:chOff x="0" y="0"/>
+          <a:chExt cx="0" cy="0"/>
+        </a:xfrm>
+      </p:grpSpPr>
+      <p:sp>
+        <p:nvSpPr>
+          <p:cNvPr id="2" name="Slide Image Placeholder 1">
+            <a:extLst>
+              <a:ext uri="{FF2B5EF4-FFF2-40B4-BE49-F238E27FC236}">
+                <a16:creationId xmlns:a16="http://schemas.microsoft.com/office/drawing/2014/main" id="{4EAF804F-F00E-C179-0AAE-72B4543DE90E}"/>
+              </a:ext>
+            </a:extLst>
+          </p:cNvPr>
+          <p:cNvSpPr>
+            <a:spLocks noGrp="1" noRot="1" noChangeAspect="1"/>
+          </p:cNvSpPr>
+          <p:nvPr>
+            <p:ph type="sldImg" idx="2"/>
+          </p:nvPr>
+        </p:nvSpPr>
+        <p:spPr/>
+      </p:sp>
+      <p:sp>
+        <p:nvSpPr>
+          <p:cNvPr id="3" name="Notes Placeholder 2">
+            <a:extLst>
+              <a:ext uri="{FF2B5EF4-FFF2-40B4-BE49-F238E27FC236}">
+                <a16:creationId xmlns:a16="http://schemas.microsoft.com/office/drawing/2014/main" id="{B965D18A-0721-A858-858D-57BE8BF515F9}"/>
+              </a:ext>
+            </a:extLst>
+          </p:cNvPr>
+          <p:cNvSpPr>
+            <a:spLocks noGrp="1"/>
+          </p:cNvSpPr>
+          <p:nvPr>
+            <p:ph type="body" sz="quarter" idx="3"/>
+          </p:nvPr>
+        </p:nvSpPr>
+        <p:spPr/>
+        <p:txBody>
+          <a:bodyPr/>
+          <a:lstStyle/>
+          <a:p>
+            <a:r>
+              <a:t>Introduce yourself and the strategic question. Highlight the mission of moving public health to a proactive strategy.</a:t>
+            </a:r>
+          </a:p>
+        </p:txBody>
+      </p:sp>
+      <p:sp>
+        <p:nvSpPr>
+          <p:cNvPr id="4" name="Slide Number Placeholder 3">
+            <a:extLst>
+              <a:ext uri="{FF2B5EF4-FFF2-40B4-BE49-F238E27FC236}">
+                <a16:creationId xmlns:a16="http://schemas.microsoft.com/office/drawing/2014/main" id="{568D48B8-6118-E56E-C07B-3E42E03039A5}"/>
+              </a:ext>
+            </a:extLst>
+          </p:cNvPr>
+          <p:cNvSpPr>
+            <a:spLocks noGrp="1"/>
+          </p:cNvSpPr>
+          <p:nvPr>
+            <p:ph type="sldNum" sz="quarter" idx="5"/>
+          </p:nvPr>
+        </p:nvSpPr>
+        <p:spPr/>
+      </p:sp>
+    </p:spTree>
+    <p:extLst>
+      <p:ext uri="{BB962C8B-B14F-4D97-AF65-F5344CB8AC3E}">
+        <p14:creationId xmlns:p14="http://schemas.microsoft.com/office/powerpoint/2010/main" val="3379349017"/>
+      </p:ext>
+    </p:extLst>
+  </p:cSld>
+  <p:clrMapOvr>
+    <a:masterClrMapping/>
+  </p:clrMapOvr>
+</p:notes>
+</file>
+
+<file path=ppt/notesSlides/notesSlide12.xml><?xml version="1.0" encoding="utf-8"?>
+<p:notes xmlns:a="http://schemas.openxmlformats.org/drawingml/2006/main" xmlns:r="http://schemas.openxmlformats.org/officeDocument/2006/relationships" xmlns:p="http://schemas.openxmlformats.org/presentationml/2006/main">
+  <p:cSld>
+    <p:spTree>
+      <p:nvGrpSpPr>
+        <p:cNvPr id="1" name="">
+          <a:extLst>
+            <a:ext uri="{FF2B5EF4-FFF2-40B4-BE49-F238E27FC236}">
               <a16:creationId xmlns:a16="http://schemas.microsoft.com/office/drawing/2014/main" id="{287CF2AB-A402-5541-4399-ED1CA84FC941}"/>
             </a:ext>
           </a:extLst>
@@ -478,7 +678,7 @@
 </p:notes>
 </file>
 
-<file path=ppt/notesSlides/notesSlide11.xml><?xml version="1.0" encoding="utf-8"?>
+<file path=ppt/notesSlides/notesSlide13.xml><?xml version="1.0" encoding="utf-8"?>
 <p:notes xmlns:a="http://schemas.openxmlformats.org/drawingml/2006/main" xmlns:r="http://schemas.openxmlformats.org/officeDocument/2006/relationships" xmlns:p="http://schemas.openxmlformats.org/presentationml/2006/main">
   <p:cSld>
     <p:spTree>
@@ -577,7 +777,7 @@
 </p:notes>
 </file>
 
-<file path=ppt/notesSlides/notesSlide12.xml><?xml version="1.0" encoding="utf-8"?>
+<file path=ppt/notesSlides/notesSlide14.xml><?xml version="1.0" encoding="utf-8"?>
 <p:notes xmlns:a="http://schemas.openxmlformats.org/drawingml/2006/main" xmlns:r="http://schemas.openxmlformats.org/officeDocument/2006/relationships" xmlns:p="http://schemas.openxmlformats.org/presentationml/2006/main">
   <p:cSld>
     <p:spTree>
@@ -676,7 +876,7 @@
 </p:notes>
 </file>
 
-<file path=ppt/notesSlides/notesSlide13.xml><?xml version="1.0" encoding="utf-8"?>
+<file path=ppt/notesSlides/notesSlide15.xml><?xml version="1.0" encoding="utf-8"?>
 <p:notes xmlns:a="http://schemas.openxmlformats.org/drawingml/2006/main" xmlns:r="http://schemas.openxmlformats.org/officeDocument/2006/relationships" xmlns:p="http://schemas.openxmlformats.org/presentationml/2006/main">
   <p:cSld>
     <p:spTree>
@@ -775,7 +975,7 @@
 </p:notes>
 </file>
 
-<file path=ppt/notesSlides/notesSlide14.xml><?xml version="1.0" encoding="utf-8"?>
+<file path=ppt/notesSlides/notesSlide16.xml><?xml version="1.0" encoding="utf-8"?>
 <p:notes xmlns:a="http://schemas.openxmlformats.org/drawingml/2006/main" xmlns:r="http://schemas.openxmlformats.org/officeDocument/2006/relationships" xmlns:p="http://schemas.openxmlformats.org/presentationml/2006/main">
   <p:cSld>
     <p:spTree>
@@ -874,7 +1074,7 @@
 </p:notes>
 </file>
 
-<file path=ppt/notesSlides/notesSlide15.xml><?xml version="1.0" encoding="utf-8"?>
+<file path=ppt/notesSlides/notesSlide17.xml><?xml version="1.0" encoding="utf-8"?>
 <p:notes xmlns:a="http://schemas.openxmlformats.org/drawingml/2006/main" xmlns:r="http://schemas.openxmlformats.org/officeDocument/2006/relationships" xmlns:p="http://schemas.openxmlformats.org/presentationml/2006/main">
   <p:cSld>
     <p:spTree>
@@ -973,7 +1173,7 @@
 </p:notes>
 </file>
 
-<file path=ppt/notesSlides/notesSlide16.xml><?xml version="1.0" encoding="utf-8"?>
+<file path=ppt/notesSlides/notesSlide18.xml><?xml version="1.0" encoding="utf-8"?>
 <p:notes xmlns:a="http://schemas.openxmlformats.org/drawingml/2006/main" xmlns:r="http://schemas.openxmlformats.org/officeDocument/2006/relationships" xmlns:p="http://schemas.openxmlformats.org/presentationml/2006/main">
   <p:cSld>
     <p:spTree>
@@ -1072,7 +1272,7 @@
 </p:notes>
 </file>
 
-<file path=ppt/notesSlides/notesSlide17.xml><?xml version="1.0" encoding="utf-8"?>
+<file path=ppt/notesSlides/notesSlide19.xml><?xml version="1.0" encoding="utf-8"?>
 <p:notes xmlns:a="http://schemas.openxmlformats.org/drawingml/2006/main" xmlns:r="http://schemas.openxmlformats.org/officeDocument/2006/relationships" xmlns:p="http://schemas.openxmlformats.org/presentationml/2006/main">
   <p:cSld>
     <p:spTree>
@@ -1162,105 +1362,6 @@
     <p:extLst>
       <p:ext uri="{BB962C8B-B14F-4D97-AF65-F5344CB8AC3E}">
         <p14:creationId xmlns:p14="http://schemas.microsoft.com/office/powerpoint/2010/main" val="2158325932"/>
-      </p:ext>
-    </p:extLst>
-  </p:cSld>
-  <p:clrMapOvr>
-    <a:masterClrMapping/>
-  </p:clrMapOvr>
-</p:notes>
-</file>
-
-<file path=ppt/notesSlides/notesSlide18.xml><?xml version="1.0" encoding="utf-8"?>
-<p:notes xmlns:a="http://schemas.openxmlformats.org/drawingml/2006/main" xmlns:r="http://schemas.openxmlformats.org/officeDocument/2006/relationships" xmlns:p="http://schemas.openxmlformats.org/presentationml/2006/main">
-  <p:cSld>
-    <p:spTree>
-      <p:nvGrpSpPr>
-        <p:cNvPr id="1" name="">
-          <a:extLst>
-            <a:ext uri="{FF2B5EF4-FFF2-40B4-BE49-F238E27FC236}">
-              <a16:creationId xmlns:a16="http://schemas.microsoft.com/office/drawing/2014/main" id="{9B1531AD-786E-8BF6-4A8B-AF260E5F43EE}"/>
-            </a:ext>
-          </a:extLst>
-        </p:cNvPr>
-        <p:cNvGrpSpPr/>
-        <p:nvPr/>
-      </p:nvGrpSpPr>
-      <p:grpSpPr>
-        <a:xfrm>
-          <a:off x="0" y="0"/>
-          <a:ext cx="0" cy="0"/>
-          <a:chOff x="0" y="0"/>
-          <a:chExt cx="0" cy="0"/>
-        </a:xfrm>
-      </p:grpSpPr>
-      <p:sp>
-        <p:nvSpPr>
-          <p:cNvPr id="2" name="Slide Image Placeholder 1">
-            <a:extLst>
-              <a:ext uri="{FF2B5EF4-FFF2-40B4-BE49-F238E27FC236}">
-                <a16:creationId xmlns:a16="http://schemas.microsoft.com/office/drawing/2014/main" id="{D9F039A0-50EC-5E35-D1B0-C5AF47EFFB99}"/>
-              </a:ext>
-            </a:extLst>
-          </p:cNvPr>
-          <p:cNvSpPr>
-            <a:spLocks noGrp="1" noRot="1" noChangeAspect="1"/>
-          </p:cNvSpPr>
-          <p:nvPr>
-            <p:ph type="sldImg" idx="2"/>
-          </p:nvPr>
-        </p:nvSpPr>
-        <p:spPr/>
-      </p:sp>
-      <p:sp>
-        <p:nvSpPr>
-          <p:cNvPr id="3" name="Notes Placeholder 2">
-            <a:extLst>
-              <a:ext uri="{FF2B5EF4-FFF2-40B4-BE49-F238E27FC236}">
-                <a16:creationId xmlns:a16="http://schemas.microsoft.com/office/drawing/2014/main" id="{FD77C799-AAE4-B0A9-5AC3-4CF69B0CA9A0}"/>
-              </a:ext>
-            </a:extLst>
-          </p:cNvPr>
-          <p:cNvSpPr>
-            <a:spLocks noGrp="1"/>
-          </p:cNvSpPr>
-          <p:nvPr>
-            <p:ph type="body" sz="quarter" idx="3"/>
-          </p:nvPr>
-        </p:nvSpPr>
-        <p:spPr/>
-        <p:txBody>
-          <a:bodyPr/>
-          <a:lstStyle/>
-          <a:p>
-            <a:r>
-              <a:t>Discuss how education and income influence uptake and the importance of simplifying messages.</a:t>
-            </a:r>
-          </a:p>
-        </p:txBody>
-      </p:sp>
-      <p:sp>
-        <p:nvSpPr>
-          <p:cNvPr id="4" name="Slide Number Placeholder 3">
-            <a:extLst>
-              <a:ext uri="{FF2B5EF4-FFF2-40B4-BE49-F238E27FC236}">
-                <a16:creationId xmlns:a16="http://schemas.microsoft.com/office/drawing/2014/main" id="{26728965-01D4-60DE-D086-A227AA6987BE}"/>
-              </a:ext>
-            </a:extLst>
-          </p:cNvPr>
-          <p:cNvSpPr>
-            <a:spLocks noGrp="1"/>
-          </p:cNvSpPr>
-          <p:nvPr>
-            <p:ph type="sldNum" sz="quarter" idx="5"/>
-          </p:nvPr>
-        </p:nvSpPr>
-        <p:spPr/>
-      </p:sp>
-    </p:spTree>
-    <p:extLst>
-      <p:ext uri="{BB962C8B-B14F-4D97-AF65-F5344CB8AC3E}">
-        <p14:creationId xmlns:p14="http://schemas.microsoft.com/office/powerpoint/2010/main" val="3263038664"/>
       </p:ext>
     </p:extLst>
   </p:cSld>
@@ -1369,7 +1470,304 @@
 </p:notes>
 </file>
 
+<file path=ppt/notesSlides/notesSlide20.xml><?xml version="1.0" encoding="utf-8"?>
+<p:notes xmlns:a="http://schemas.openxmlformats.org/drawingml/2006/main" xmlns:r="http://schemas.openxmlformats.org/officeDocument/2006/relationships" xmlns:p="http://schemas.openxmlformats.org/presentationml/2006/main">
+  <p:cSld>
+    <p:spTree>
+      <p:nvGrpSpPr>
+        <p:cNvPr id="1" name="">
+          <a:extLst>
+            <a:ext uri="{FF2B5EF4-FFF2-40B4-BE49-F238E27FC236}">
+              <a16:creationId xmlns:a16="http://schemas.microsoft.com/office/drawing/2014/main" id="{9B1531AD-786E-8BF6-4A8B-AF260E5F43EE}"/>
+            </a:ext>
+          </a:extLst>
+        </p:cNvPr>
+        <p:cNvGrpSpPr/>
+        <p:nvPr/>
+      </p:nvGrpSpPr>
+      <p:grpSpPr>
+        <a:xfrm>
+          <a:off x="0" y="0"/>
+          <a:ext cx="0" cy="0"/>
+          <a:chOff x="0" y="0"/>
+          <a:chExt cx="0" cy="0"/>
+        </a:xfrm>
+      </p:grpSpPr>
+      <p:sp>
+        <p:nvSpPr>
+          <p:cNvPr id="2" name="Slide Image Placeholder 1">
+            <a:extLst>
+              <a:ext uri="{FF2B5EF4-FFF2-40B4-BE49-F238E27FC236}">
+                <a16:creationId xmlns:a16="http://schemas.microsoft.com/office/drawing/2014/main" id="{D9F039A0-50EC-5E35-D1B0-C5AF47EFFB99}"/>
+              </a:ext>
+            </a:extLst>
+          </p:cNvPr>
+          <p:cNvSpPr>
+            <a:spLocks noGrp="1" noRot="1" noChangeAspect="1"/>
+          </p:cNvSpPr>
+          <p:nvPr>
+            <p:ph type="sldImg" idx="2"/>
+          </p:nvPr>
+        </p:nvSpPr>
+        <p:spPr/>
+      </p:sp>
+      <p:sp>
+        <p:nvSpPr>
+          <p:cNvPr id="3" name="Notes Placeholder 2">
+            <a:extLst>
+              <a:ext uri="{FF2B5EF4-FFF2-40B4-BE49-F238E27FC236}">
+                <a16:creationId xmlns:a16="http://schemas.microsoft.com/office/drawing/2014/main" id="{FD77C799-AAE4-B0A9-5AC3-4CF69B0CA9A0}"/>
+              </a:ext>
+            </a:extLst>
+          </p:cNvPr>
+          <p:cNvSpPr>
+            <a:spLocks noGrp="1"/>
+          </p:cNvSpPr>
+          <p:nvPr>
+            <p:ph type="body" sz="quarter" idx="3"/>
+          </p:nvPr>
+        </p:nvSpPr>
+        <p:spPr/>
+        <p:txBody>
+          <a:bodyPr/>
+          <a:lstStyle/>
+          <a:p>
+            <a:r>
+              <a:t>Discuss how education and income influence uptake and the importance of simplifying messages.</a:t>
+            </a:r>
+          </a:p>
+        </p:txBody>
+      </p:sp>
+      <p:sp>
+        <p:nvSpPr>
+          <p:cNvPr id="4" name="Slide Number Placeholder 3">
+            <a:extLst>
+              <a:ext uri="{FF2B5EF4-FFF2-40B4-BE49-F238E27FC236}">
+                <a16:creationId xmlns:a16="http://schemas.microsoft.com/office/drawing/2014/main" id="{26728965-01D4-60DE-D086-A227AA6987BE}"/>
+              </a:ext>
+            </a:extLst>
+          </p:cNvPr>
+          <p:cNvSpPr>
+            <a:spLocks noGrp="1"/>
+          </p:cNvSpPr>
+          <p:nvPr>
+            <p:ph type="sldNum" sz="quarter" idx="5"/>
+          </p:nvPr>
+        </p:nvSpPr>
+        <p:spPr/>
+      </p:sp>
+    </p:spTree>
+    <p:extLst>
+      <p:ext uri="{BB962C8B-B14F-4D97-AF65-F5344CB8AC3E}">
+        <p14:creationId xmlns:p14="http://schemas.microsoft.com/office/powerpoint/2010/main" val="3263038664"/>
+      </p:ext>
+    </p:extLst>
+  </p:cSld>
+  <p:clrMapOvr>
+    <a:masterClrMapping/>
+  </p:clrMapOvr>
+</p:notes>
+</file>
+
 <file path=ppt/notesSlides/notesSlide3.xml><?xml version="1.0" encoding="utf-8"?>
+<p:notes xmlns:a="http://schemas.openxmlformats.org/drawingml/2006/main" xmlns:r="http://schemas.openxmlformats.org/officeDocument/2006/relationships" xmlns:p="http://schemas.openxmlformats.org/presentationml/2006/main">
+  <p:cSld>
+    <p:spTree>
+      <p:nvGrpSpPr>
+        <p:cNvPr id="1" name="">
+          <a:extLst>
+            <a:ext uri="{FF2B5EF4-FFF2-40B4-BE49-F238E27FC236}">
+              <a16:creationId xmlns:a16="http://schemas.microsoft.com/office/drawing/2014/main" id="{58F294E9-FE19-E781-CC9A-79E6CA8C9C1E}"/>
+            </a:ext>
+          </a:extLst>
+        </p:cNvPr>
+        <p:cNvGrpSpPr/>
+        <p:nvPr/>
+      </p:nvGrpSpPr>
+      <p:grpSpPr>
+        <a:xfrm>
+          <a:off x="0" y="0"/>
+          <a:ext cx="0" cy="0"/>
+          <a:chOff x="0" y="0"/>
+          <a:chExt cx="0" cy="0"/>
+        </a:xfrm>
+      </p:grpSpPr>
+      <p:sp>
+        <p:nvSpPr>
+          <p:cNvPr id="2" name="Slide Image Placeholder 1">
+            <a:extLst>
+              <a:ext uri="{FF2B5EF4-FFF2-40B4-BE49-F238E27FC236}">
+                <a16:creationId xmlns:a16="http://schemas.microsoft.com/office/drawing/2014/main" id="{F3DF8C13-410B-631C-5780-7D01A7F58E05}"/>
+              </a:ext>
+            </a:extLst>
+          </p:cNvPr>
+          <p:cNvSpPr>
+            <a:spLocks noGrp="1" noRot="1" noChangeAspect="1"/>
+          </p:cNvSpPr>
+          <p:nvPr>
+            <p:ph type="sldImg" idx="2"/>
+          </p:nvPr>
+        </p:nvSpPr>
+        <p:spPr/>
+      </p:sp>
+      <p:sp>
+        <p:nvSpPr>
+          <p:cNvPr id="3" name="Notes Placeholder 2">
+            <a:extLst>
+              <a:ext uri="{FF2B5EF4-FFF2-40B4-BE49-F238E27FC236}">
+                <a16:creationId xmlns:a16="http://schemas.microsoft.com/office/drawing/2014/main" id="{543BDE0B-EC25-4F70-660D-8696DBF4DB30}"/>
+              </a:ext>
+            </a:extLst>
+          </p:cNvPr>
+          <p:cNvSpPr>
+            <a:spLocks noGrp="1"/>
+          </p:cNvSpPr>
+          <p:nvPr>
+            <p:ph type="body" sz="quarter" idx="3"/>
+          </p:nvPr>
+        </p:nvSpPr>
+        <p:spPr/>
+        <p:txBody>
+          <a:bodyPr/>
+          <a:lstStyle/>
+          <a:p>
+            <a:r>
+              <a:t>Introduce yourself and the strategic question. Highlight the mission of moving public health to a proactive strategy.</a:t>
+            </a:r>
+          </a:p>
+        </p:txBody>
+      </p:sp>
+      <p:sp>
+        <p:nvSpPr>
+          <p:cNvPr id="4" name="Slide Number Placeholder 3">
+            <a:extLst>
+              <a:ext uri="{FF2B5EF4-FFF2-40B4-BE49-F238E27FC236}">
+                <a16:creationId xmlns:a16="http://schemas.microsoft.com/office/drawing/2014/main" id="{11A07338-584D-3F07-5A77-1D82169A889B}"/>
+              </a:ext>
+            </a:extLst>
+          </p:cNvPr>
+          <p:cNvSpPr>
+            <a:spLocks noGrp="1"/>
+          </p:cNvSpPr>
+          <p:nvPr>
+            <p:ph type="sldNum" sz="quarter" idx="5"/>
+          </p:nvPr>
+        </p:nvSpPr>
+        <p:spPr/>
+      </p:sp>
+    </p:spTree>
+    <p:extLst>
+      <p:ext uri="{BB962C8B-B14F-4D97-AF65-F5344CB8AC3E}">
+        <p14:creationId xmlns:p14="http://schemas.microsoft.com/office/powerpoint/2010/main" val="226106009"/>
+      </p:ext>
+    </p:extLst>
+  </p:cSld>
+  <p:clrMapOvr>
+    <a:masterClrMapping/>
+  </p:clrMapOvr>
+</p:notes>
+</file>
+
+<file path=ppt/notesSlides/notesSlide4.xml><?xml version="1.0" encoding="utf-8"?>
+<p:notes xmlns:a="http://schemas.openxmlformats.org/drawingml/2006/main" xmlns:r="http://schemas.openxmlformats.org/officeDocument/2006/relationships" xmlns:p="http://schemas.openxmlformats.org/presentationml/2006/main">
+  <p:cSld>
+    <p:spTree>
+      <p:nvGrpSpPr>
+        <p:cNvPr id="1" name="">
+          <a:extLst>
+            <a:ext uri="{FF2B5EF4-FFF2-40B4-BE49-F238E27FC236}">
+              <a16:creationId xmlns:a16="http://schemas.microsoft.com/office/drawing/2014/main" id="{75EFC1C9-D1D6-EC12-DB72-9255B394801B}"/>
+            </a:ext>
+          </a:extLst>
+        </p:cNvPr>
+        <p:cNvGrpSpPr/>
+        <p:nvPr/>
+      </p:nvGrpSpPr>
+      <p:grpSpPr>
+        <a:xfrm>
+          <a:off x="0" y="0"/>
+          <a:ext cx="0" cy="0"/>
+          <a:chOff x="0" y="0"/>
+          <a:chExt cx="0" cy="0"/>
+        </a:xfrm>
+      </p:grpSpPr>
+      <p:sp>
+        <p:nvSpPr>
+          <p:cNvPr id="2" name="Slide Image Placeholder 1">
+            <a:extLst>
+              <a:ext uri="{FF2B5EF4-FFF2-40B4-BE49-F238E27FC236}">
+                <a16:creationId xmlns:a16="http://schemas.microsoft.com/office/drawing/2014/main" id="{E961896B-5F33-2874-F49E-5ECBF7F17DD3}"/>
+              </a:ext>
+            </a:extLst>
+          </p:cNvPr>
+          <p:cNvSpPr>
+            <a:spLocks noGrp="1" noRot="1" noChangeAspect="1"/>
+          </p:cNvSpPr>
+          <p:nvPr>
+            <p:ph type="sldImg" idx="2"/>
+          </p:nvPr>
+        </p:nvSpPr>
+        <p:spPr/>
+      </p:sp>
+      <p:sp>
+        <p:nvSpPr>
+          <p:cNvPr id="3" name="Notes Placeholder 2">
+            <a:extLst>
+              <a:ext uri="{FF2B5EF4-FFF2-40B4-BE49-F238E27FC236}">
+                <a16:creationId xmlns:a16="http://schemas.microsoft.com/office/drawing/2014/main" id="{E25F2C3C-3ECD-B1C9-A148-A82401752511}"/>
+              </a:ext>
+            </a:extLst>
+          </p:cNvPr>
+          <p:cNvSpPr>
+            <a:spLocks noGrp="1"/>
+          </p:cNvSpPr>
+          <p:nvPr>
+            <p:ph type="body" sz="quarter" idx="3"/>
+          </p:nvPr>
+        </p:nvSpPr>
+        <p:spPr/>
+        <p:txBody>
+          <a:bodyPr/>
+          <a:lstStyle/>
+          <a:p>
+            <a:r>
+              <a:t>Introduce yourself and the strategic question. Highlight the mission of moving public health to a proactive strategy.</a:t>
+            </a:r>
+          </a:p>
+        </p:txBody>
+      </p:sp>
+      <p:sp>
+        <p:nvSpPr>
+          <p:cNvPr id="4" name="Slide Number Placeholder 3">
+            <a:extLst>
+              <a:ext uri="{FF2B5EF4-FFF2-40B4-BE49-F238E27FC236}">
+                <a16:creationId xmlns:a16="http://schemas.microsoft.com/office/drawing/2014/main" id="{9BF27917-1569-E672-D342-7AEB33EE285A}"/>
+              </a:ext>
+            </a:extLst>
+          </p:cNvPr>
+          <p:cNvSpPr>
+            <a:spLocks noGrp="1"/>
+          </p:cNvSpPr>
+          <p:nvPr>
+            <p:ph type="sldNum" sz="quarter" idx="5"/>
+          </p:nvPr>
+        </p:nvSpPr>
+        <p:spPr/>
+      </p:sp>
+    </p:spTree>
+    <p:extLst>
+      <p:ext uri="{BB962C8B-B14F-4D97-AF65-F5344CB8AC3E}">
+        <p14:creationId xmlns:p14="http://schemas.microsoft.com/office/powerpoint/2010/main" val="4071601414"/>
+      </p:ext>
+    </p:extLst>
+  </p:cSld>
+  <p:clrMapOvr>
+    <a:masterClrMapping/>
+  </p:clrMapOvr>
+</p:notes>
+</file>
+
+<file path=ppt/notesSlides/notesSlide5.xml><?xml version="1.0" encoding="utf-8"?>
 <p:notes xmlns:a="http://schemas.openxmlformats.org/drawingml/2006/main" xmlns:r="http://schemas.openxmlformats.org/officeDocument/2006/relationships" xmlns:p="http://schemas.openxmlformats.org/presentationml/2006/main">
   <p:cSld>
     <p:spTree>
@@ -1468,7 +1866,7 @@
 </p:notes>
 </file>
 
-<file path=ppt/notesSlides/notesSlide4.xml><?xml version="1.0" encoding="utf-8"?>
+<file path=ppt/notesSlides/notesSlide6.xml><?xml version="1.0" encoding="utf-8"?>
 <p:notes xmlns:a="http://schemas.openxmlformats.org/drawingml/2006/main" xmlns:r="http://schemas.openxmlformats.org/officeDocument/2006/relationships" xmlns:p="http://schemas.openxmlformats.org/presentationml/2006/main">
   <p:cSld>
     <p:spTree>
@@ -1567,7 +1965,7 @@
 </p:notes>
 </file>
 
-<file path=ppt/notesSlides/notesSlide5.xml><?xml version="1.0" encoding="utf-8"?>
+<file path=ppt/notesSlides/notesSlide7.xml><?xml version="1.0" encoding="utf-8"?>
 <p:notes xmlns:a="http://schemas.openxmlformats.org/drawingml/2006/main" xmlns:r="http://schemas.openxmlformats.org/officeDocument/2006/relationships" xmlns:p="http://schemas.openxmlformats.org/presentationml/2006/main">
   <p:cSld>
     <p:spTree>
@@ -1666,7 +2064,7 @@
 </p:notes>
 </file>
 
-<file path=ppt/notesSlides/notesSlide6.xml><?xml version="1.0" encoding="utf-8"?>
+<file path=ppt/notesSlides/notesSlide8.xml><?xml version="1.0" encoding="utf-8"?>
 <p:notes xmlns:a="http://schemas.openxmlformats.org/drawingml/2006/main" xmlns:r="http://schemas.openxmlformats.org/officeDocument/2006/relationships" xmlns:p="http://schemas.openxmlformats.org/presentationml/2006/main">
   <p:cSld>
     <p:spTree>
@@ -1765,7 +2163,7 @@
 </p:notes>
 </file>
 
-<file path=ppt/notesSlides/notesSlide7.xml><?xml version="1.0" encoding="utf-8"?>
+<file path=ppt/notesSlides/notesSlide9.xml><?xml version="1.0" encoding="utf-8"?>
 <p:notes xmlns:a="http://schemas.openxmlformats.org/drawingml/2006/main" xmlns:r="http://schemas.openxmlformats.org/officeDocument/2006/relationships" xmlns:p="http://schemas.openxmlformats.org/presentationml/2006/main">
   <p:cSld>
     <p:spTree>
@@ -1855,204 +2253,6 @@
     <p:extLst>
       <p:ext uri="{BB962C8B-B14F-4D97-AF65-F5344CB8AC3E}">
         <p14:creationId xmlns:p14="http://schemas.microsoft.com/office/powerpoint/2010/main" val="263507152"/>
-      </p:ext>
-    </p:extLst>
-  </p:cSld>
-  <p:clrMapOvr>
-    <a:masterClrMapping/>
-  </p:clrMapOvr>
-</p:notes>
-</file>
-
-<file path=ppt/notesSlides/notesSlide8.xml><?xml version="1.0" encoding="utf-8"?>
-<p:notes xmlns:a="http://schemas.openxmlformats.org/drawingml/2006/main" xmlns:r="http://schemas.openxmlformats.org/officeDocument/2006/relationships" xmlns:p="http://schemas.openxmlformats.org/presentationml/2006/main">
-  <p:cSld>
-    <p:spTree>
-      <p:nvGrpSpPr>
-        <p:cNvPr id="1" name="">
-          <a:extLst>
-            <a:ext uri="{FF2B5EF4-FFF2-40B4-BE49-F238E27FC236}">
-              <a16:creationId xmlns:a16="http://schemas.microsoft.com/office/drawing/2014/main" id="{0D83B98D-6582-52CE-D0A1-AF5EAC7E1EEE}"/>
-            </a:ext>
-          </a:extLst>
-        </p:cNvPr>
-        <p:cNvGrpSpPr/>
-        <p:nvPr/>
-      </p:nvGrpSpPr>
-      <p:grpSpPr>
-        <a:xfrm>
-          <a:off x="0" y="0"/>
-          <a:ext cx="0" cy="0"/>
-          <a:chOff x="0" y="0"/>
-          <a:chExt cx="0" cy="0"/>
-        </a:xfrm>
-      </p:grpSpPr>
-      <p:sp>
-        <p:nvSpPr>
-          <p:cNvPr id="2" name="Slide Image Placeholder 1">
-            <a:extLst>
-              <a:ext uri="{FF2B5EF4-FFF2-40B4-BE49-F238E27FC236}">
-                <a16:creationId xmlns:a16="http://schemas.microsoft.com/office/drawing/2014/main" id="{BA8BE577-F512-9FA4-95BD-E3809350923B}"/>
-              </a:ext>
-            </a:extLst>
-          </p:cNvPr>
-          <p:cNvSpPr>
-            <a:spLocks noGrp="1" noRot="1" noChangeAspect="1"/>
-          </p:cNvSpPr>
-          <p:nvPr>
-            <p:ph type="sldImg" idx="2"/>
-          </p:nvPr>
-        </p:nvSpPr>
-        <p:spPr/>
-      </p:sp>
-      <p:sp>
-        <p:nvSpPr>
-          <p:cNvPr id="3" name="Notes Placeholder 2">
-            <a:extLst>
-              <a:ext uri="{FF2B5EF4-FFF2-40B4-BE49-F238E27FC236}">
-                <a16:creationId xmlns:a16="http://schemas.microsoft.com/office/drawing/2014/main" id="{330DC3C9-502D-57F4-D2DB-14819BD36901}"/>
-              </a:ext>
-            </a:extLst>
-          </p:cNvPr>
-          <p:cNvSpPr>
-            <a:spLocks noGrp="1"/>
-          </p:cNvSpPr>
-          <p:nvPr>
-            <p:ph type="body" sz="quarter" idx="3"/>
-          </p:nvPr>
-        </p:nvSpPr>
-        <p:spPr/>
-        <p:txBody>
-          <a:bodyPr/>
-          <a:lstStyle/>
-          <a:p>
-            <a:r>
-              <a:t>Explain the dataset, objective, and the challenge of predicting a rare event.</a:t>
-            </a:r>
-          </a:p>
-        </p:txBody>
-      </p:sp>
-      <p:sp>
-        <p:nvSpPr>
-          <p:cNvPr id="4" name="Slide Number Placeholder 3">
-            <a:extLst>
-              <a:ext uri="{FF2B5EF4-FFF2-40B4-BE49-F238E27FC236}">
-                <a16:creationId xmlns:a16="http://schemas.microsoft.com/office/drawing/2014/main" id="{E3650BA1-C114-10DC-99A2-96319CC16A40}"/>
-              </a:ext>
-            </a:extLst>
-          </p:cNvPr>
-          <p:cNvSpPr>
-            <a:spLocks noGrp="1"/>
-          </p:cNvSpPr>
-          <p:nvPr>
-            <p:ph type="sldNum" sz="quarter" idx="5"/>
-          </p:nvPr>
-        </p:nvSpPr>
-        <p:spPr/>
-      </p:sp>
-    </p:spTree>
-    <p:extLst>
-      <p:ext uri="{BB962C8B-B14F-4D97-AF65-F5344CB8AC3E}">
-        <p14:creationId xmlns:p14="http://schemas.microsoft.com/office/powerpoint/2010/main" val="2167343352"/>
-      </p:ext>
-    </p:extLst>
-  </p:cSld>
-  <p:clrMapOvr>
-    <a:masterClrMapping/>
-  </p:clrMapOvr>
-</p:notes>
-</file>
-
-<file path=ppt/notesSlides/notesSlide9.xml><?xml version="1.0" encoding="utf-8"?>
-<p:notes xmlns:a="http://schemas.openxmlformats.org/drawingml/2006/main" xmlns:r="http://schemas.openxmlformats.org/officeDocument/2006/relationships" xmlns:p="http://schemas.openxmlformats.org/presentationml/2006/main">
-  <p:cSld>
-    <p:spTree>
-      <p:nvGrpSpPr>
-        <p:cNvPr id="1" name="">
-          <a:extLst>
-            <a:ext uri="{FF2B5EF4-FFF2-40B4-BE49-F238E27FC236}">
-              <a16:creationId xmlns:a16="http://schemas.microsoft.com/office/drawing/2014/main" id="{75831669-FC06-E49D-214F-651E93CE3444}"/>
-            </a:ext>
-          </a:extLst>
-        </p:cNvPr>
-        <p:cNvGrpSpPr/>
-        <p:nvPr/>
-      </p:nvGrpSpPr>
-      <p:grpSpPr>
-        <a:xfrm>
-          <a:off x="0" y="0"/>
-          <a:ext cx="0" cy="0"/>
-          <a:chOff x="0" y="0"/>
-          <a:chExt cx="0" cy="0"/>
-        </a:xfrm>
-      </p:grpSpPr>
-      <p:sp>
-        <p:nvSpPr>
-          <p:cNvPr id="2" name="Slide Image Placeholder 1">
-            <a:extLst>
-              <a:ext uri="{FF2B5EF4-FFF2-40B4-BE49-F238E27FC236}">
-                <a16:creationId xmlns:a16="http://schemas.microsoft.com/office/drawing/2014/main" id="{4EAF804F-F00E-C179-0AAE-72B4543DE90E}"/>
-              </a:ext>
-            </a:extLst>
-          </p:cNvPr>
-          <p:cNvSpPr>
-            <a:spLocks noGrp="1" noRot="1" noChangeAspect="1"/>
-          </p:cNvSpPr>
-          <p:nvPr>
-            <p:ph type="sldImg" idx="2"/>
-          </p:nvPr>
-        </p:nvSpPr>
-        <p:spPr/>
-      </p:sp>
-      <p:sp>
-        <p:nvSpPr>
-          <p:cNvPr id="3" name="Notes Placeholder 2">
-            <a:extLst>
-              <a:ext uri="{FF2B5EF4-FFF2-40B4-BE49-F238E27FC236}">
-                <a16:creationId xmlns:a16="http://schemas.microsoft.com/office/drawing/2014/main" id="{B965D18A-0721-A858-858D-57BE8BF515F9}"/>
-              </a:ext>
-            </a:extLst>
-          </p:cNvPr>
-          <p:cNvSpPr>
-            <a:spLocks noGrp="1"/>
-          </p:cNvSpPr>
-          <p:nvPr>
-            <p:ph type="body" sz="quarter" idx="3"/>
-          </p:nvPr>
-        </p:nvSpPr>
-        <p:spPr/>
-        <p:txBody>
-          <a:bodyPr/>
-          <a:lstStyle/>
-          <a:p>
-            <a:r>
-              <a:t>Introduce yourself and the strategic question. Highlight the mission of moving public health to a proactive strategy.</a:t>
-            </a:r>
-          </a:p>
-        </p:txBody>
-      </p:sp>
-      <p:sp>
-        <p:nvSpPr>
-          <p:cNvPr id="4" name="Slide Number Placeholder 3">
-            <a:extLst>
-              <a:ext uri="{FF2B5EF4-FFF2-40B4-BE49-F238E27FC236}">
-                <a16:creationId xmlns:a16="http://schemas.microsoft.com/office/drawing/2014/main" id="{568D48B8-6118-E56E-C07B-3E42E03039A5}"/>
-              </a:ext>
-            </a:extLst>
-          </p:cNvPr>
-          <p:cNvSpPr>
-            <a:spLocks noGrp="1"/>
-          </p:cNvSpPr>
-          <p:nvPr>
-            <p:ph type="sldNum" sz="quarter" idx="5"/>
-          </p:nvPr>
-        </p:nvSpPr>
-        <p:spPr/>
-      </p:sp>
-    </p:spTree>
-    <p:extLst>
-      <p:ext uri="{BB962C8B-B14F-4D97-AF65-F5344CB8AC3E}">
-        <p14:creationId xmlns:p14="http://schemas.microsoft.com/office/powerpoint/2010/main" val="3379349017"/>
       </p:ext>
     </p:extLst>
   </p:cSld>
@@ -7849,8 +8049,8 @@
         </p:nvSpPr>
         <p:spPr>
           <a:xfrm>
-            <a:off x="625033" y="763929"/>
-            <a:ext cx="7836062" cy="1747776"/>
+            <a:off x="491924" y="682906"/>
+            <a:ext cx="8160152" cy="1747776"/>
           </a:xfrm>
         </p:spPr>
         <p:txBody>
@@ -7870,19 +8070,13 @@
                 <a:latin typeface="Garamond" panose="02020404030301010803" pitchFamily="18" charset="0"/>
               </a:rPr>
             </a:br>
-            <a:r>
-              <a:rPr lang="en-US" sz="1600" dirty="0">
-                <a:latin typeface="Garamond" panose="02020404030301010803" pitchFamily="18" charset="0"/>
-              </a:rPr>
-              <a:t>Predicting Vaccine Intent Before the Next Outbreak</a:t>
-            </a:r>
             <a:br>
               <a:rPr lang="en-US" sz="2400" dirty="0">
                 <a:latin typeface="Garamond" panose="02020404030301010803" pitchFamily="18" charset="0"/>
               </a:rPr>
             </a:br>
             <a:r>
-              <a:rPr lang="en-US" sz="1600" b="1" dirty="0">
+              <a:rPr lang="en-US" sz="1800" b="1" dirty="0">
                 <a:latin typeface="Garamond" panose="02020404030301010803" pitchFamily="18" charset="0"/>
               </a:rPr>
               <a:t>“In a public health crisis, every dollar spent on the wrong outreach can cost lives.”</a:t>
@@ -7916,8 +8110,8 @@
         </p:nvSpPr>
         <p:spPr>
           <a:xfrm>
-            <a:off x="1655179" y="2511706"/>
-            <a:ext cx="6227179" cy="3728228"/>
+            <a:off x="1655179" y="2233914"/>
+            <a:ext cx="6227179" cy="4294208"/>
           </a:xfrm>
         </p:spPr>
         <p:txBody>
@@ -7943,8 +8137,6 @@
               </a:rPr>
               <a:t>How do we predict who will say ‘Yes’ in advance?</a:t>
             </a:r>
-          </a:p>
-          <a:p>
             <a:endParaRPr lang="en-US" dirty="0">
               <a:latin typeface="Garamond" panose="02020404030301010803" pitchFamily="18" charset="0"/>
             </a:endParaRPr>
@@ -8107,6 +8299,424 @@
 </file>
 
 <file path=ppt/slides/slide10.xml><?xml version="1.0" encoding="utf-8"?>
+<p:sld xmlns:a="http://schemas.openxmlformats.org/drawingml/2006/main" xmlns:r="http://schemas.openxmlformats.org/officeDocument/2006/relationships" xmlns:p="http://schemas.openxmlformats.org/presentationml/2006/main">
+  <p:cSld>
+    <p:spTree>
+      <p:nvGrpSpPr>
+        <p:cNvPr id="1" name="">
+          <a:extLst>
+            <a:ext uri="{FF2B5EF4-FFF2-40B4-BE49-F238E27FC236}">
+              <a16:creationId xmlns:a16="http://schemas.microsoft.com/office/drawing/2014/main" id="{E7487181-9552-270E-C500-0B6E4EED9D15}"/>
+            </a:ext>
+          </a:extLst>
+        </p:cNvPr>
+        <p:cNvGrpSpPr/>
+        <p:nvPr/>
+      </p:nvGrpSpPr>
+      <p:grpSpPr>
+        <a:xfrm>
+          <a:off x="0" y="0"/>
+          <a:ext cx="0" cy="0"/>
+          <a:chOff x="0" y="0"/>
+          <a:chExt cx="0" cy="0"/>
+        </a:xfrm>
+      </p:grpSpPr>
+      <p:sp>
+        <p:nvSpPr>
+          <p:cNvPr id="2" name="Title 1">
+            <a:extLst>
+              <a:ext uri="{FF2B5EF4-FFF2-40B4-BE49-F238E27FC236}">
+                <a16:creationId xmlns:a16="http://schemas.microsoft.com/office/drawing/2014/main" id="{7DBF6588-C9F8-B5D3-086F-6EA1ADC3336F}"/>
+              </a:ext>
+            </a:extLst>
+          </p:cNvPr>
+          <p:cNvSpPr>
+            <a:spLocks noGrp="1"/>
+          </p:cNvSpPr>
+          <p:nvPr>
+            <p:ph type="title"/>
+          </p:nvPr>
+        </p:nvSpPr>
+        <p:spPr/>
+        <p:txBody>
+          <a:bodyPr>
+            <a:normAutofit/>
+          </a:bodyPr>
+          <a:lstStyle/>
+          <a:p>
+            <a:r>
+              <a:rPr lang="en-US" sz="3600" b="1" dirty="0">
+                <a:latin typeface="Garamond" panose="02020404030301010803" pitchFamily="18" charset="0"/>
+              </a:rPr>
+              <a:t>Escaping the Accuracy Trap</a:t>
+            </a:r>
+            <a:br>
+              <a:rPr lang="en-US" sz="3600" b="1" dirty="0">
+                <a:latin typeface="Garamond" panose="02020404030301010803" pitchFamily="18" charset="0"/>
+              </a:rPr>
+            </a:br>
+            <a:r>
+              <a:rPr lang="en-US" sz="2700" dirty="0">
+                <a:latin typeface="Garamond" panose="02020404030301010803" pitchFamily="18" charset="0"/>
+              </a:rPr>
+              <a:t>Prioritizing Recall Over Accuracy</a:t>
+            </a:r>
+          </a:p>
+        </p:txBody>
+      </p:sp>
+      <p:sp>
+        <p:nvSpPr>
+          <p:cNvPr id="3" name="Content Placeholder 2">
+            <a:extLst>
+              <a:ext uri="{FF2B5EF4-FFF2-40B4-BE49-F238E27FC236}">
+                <a16:creationId xmlns:a16="http://schemas.microsoft.com/office/drawing/2014/main" id="{F2E71823-E482-82DF-AD19-6AFE5CB1B331}"/>
+              </a:ext>
+            </a:extLst>
+          </p:cNvPr>
+          <p:cNvSpPr>
+            <a:spLocks noGrp="1"/>
+          </p:cNvSpPr>
+          <p:nvPr>
+            <p:ph idx="1"/>
+          </p:nvPr>
+        </p:nvSpPr>
+        <p:spPr/>
+        <p:txBody>
+          <a:bodyPr>
+            <a:normAutofit fontScale="47500" lnSpcReduction="20000"/>
+          </a:bodyPr>
+          <a:lstStyle/>
+          <a:p>
+            <a:pPr marL="0" indent="0">
+              <a:buNone/>
+            </a:pPr>
+            <a:r>
+              <a:rPr lang="en-US" sz="2500" b="1" dirty="0">
+                <a:latin typeface="Garamond" panose="02020404030301010803" pitchFamily="18" charset="0"/>
+              </a:rPr>
+              <a:t>The Core Discovery</a:t>
+            </a:r>
+          </a:p>
+          <a:p>
+            <a:pPr>
+              <a:buFont typeface="Wingdings" panose="05000000000000000000" pitchFamily="2" charset="2"/>
+              <a:buChar char="q"/>
+            </a:pPr>
+            <a:r>
+              <a:rPr lang="en-US" dirty="0">
+                <a:latin typeface="Garamond" panose="02020404030301010803" pitchFamily="18" charset="0"/>
+              </a:rPr>
+              <a:t>Hygiene ≠ vaccination </a:t>
+            </a:r>
+          </a:p>
+          <a:p>
+            <a:pPr>
+              <a:buFont typeface="Wingdings" panose="05000000000000000000" pitchFamily="2" charset="2"/>
+              <a:buChar char="q"/>
+            </a:pPr>
+            <a:r>
+              <a:rPr lang="en-US" b="1" dirty="0">
+                <a:latin typeface="Garamond" panose="02020404030301010803" pitchFamily="18" charset="0"/>
+              </a:rPr>
+              <a:t>Trust in effectiveness = key driver</a:t>
+            </a:r>
+            <a:r>
+              <a:rPr lang="en-US" dirty="0">
+                <a:latin typeface="Garamond" panose="02020404030301010803" pitchFamily="18" charset="0"/>
+              </a:rPr>
+              <a:t> </a:t>
+            </a:r>
+            <a:br>
+              <a:rPr lang="en-US" dirty="0">
+                <a:latin typeface="Garamond" panose="02020404030301010803" pitchFamily="18" charset="0"/>
+              </a:rPr>
+            </a:br>
+            <a:endParaRPr lang="en-US" dirty="0">
+              <a:latin typeface="Garamond" panose="02020404030301010803" pitchFamily="18" charset="0"/>
+            </a:endParaRPr>
+          </a:p>
+          <a:p>
+            <a:pPr marL="0" indent="0">
+              <a:buNone/>
+            </a:pPr>
+            <a:r>
+              <a:rPr lang="en-US" sz="2500" b="1" dirty="0">
+                <a:latin typeface="Garamond" panose="02020404030301010803" pitchFamily="18" charset="0"/>
+              </a:rPr>
+              <a:t>The Problem with Accuracy</a:t>
+            </a:r>
+          </a:p>
+          <a:p>
+            <a:pPr>
+              <a:buFont typeface="Wingdings" panose="05000000000000000000" pitchFamily="2" charset="2"/>
+              <a:buChar char="q"/>
+            </a:pPr>
+            <a:r>
+              <a:rPr lang="en-US" dirty="0">
+                <a:latin typeface="Garamond" panose="02020404030301010803" pitchFamily="18" charset="0"/>
+              </a:rPr>
+              <a:t>79% accuracy possible by predicting “No” </a:t>
+            </a:r>
+          </a:p>
+          <a:p>
+            <a:pPr>
+              <a:buFont typeface="Wingdings" panose="05000000000000000000" pitchFamily="2" charset="2"/>
+              <a:buChar char="q"/>
+            </a:pPr>
+            <a:r>
+              <a:rPr lang="en-US" dirty="0">
+                <a:latin typeface="Garamond" panose="02020404030301010803" pitchFamily="18" charset="0"/>
+              </a:rPr>
+              <a:t>High accuracy can still fail in practice </a:t>
+            </a:r>
+            <a:br>
+              <a:rPr lang="en-US" dirty="0">
+                <a:latin typeface="Garamond" panose="02020404030301010803" pitchFamily="18" charset="0"/>
+              </a:rPr>
+            </a:br>
+            <a:endParaRPr lang="en-US" dirty="0">
+              <a:latin typeface="Garamond" panose="02020404030301010803" pitchFamily="18" charset="0"/>
+            </a:endParaRPr>
+          </a:p>
+          <a:p>
+            <a:pPr marL="0" indent="0">
+              <a:buNone/>
+            </a:pPr>
+            <a:r>
+              <a:rPr lang="en-US" sz="2900" b="1" dirty="0">
+                <a:latin typeface="Garamond" panose="02020404030301010803" pitchFamily="18" charset="0"/>
+              </a:rPr>
+              <a:t>The Strategic Pivot</a:t>
+            </a:r>
+          </a:p>
+          <a:p>
+            <a:pPr>
+              <a:buFont typeface="Wingdings" panose="05000000000000000000" pitchFamily="2" charset="2"/>
+              <a:buChar char="q"/>
+            </a:pPr>
+            <a:r>
+              <a:rPr lang="en-US" dirty="0">
+                <a:latin typeface="Garamond" panose="02020404030301010803" pitchFamily="18" charset="0"/>
+              </a:rPr>
+              <a:t>Focus on </a:t>
+            </a:r>
+            <a:r>
+              <a:rPr lang="en-US" b="1" dirty="0">
+                <a:latin typeface="Garamond" panose="02020404030301010803" pitchFamily="18" charset="0"/>
+              </a:rPr>
+              <a:t>Recall (find potential vaccinees)</a:t>
+            </a:r>
+            <a:r>
+              <a:rPr lang="en-US" dirty="0">
+                <a:latin typeface="Garamond" panose="02020404030301010803" pitchFamily="18" charset="0"/>
+              </a:rPr>
+              <a:t> </a:t>
+            </a:r>
+          </a:p>
+          <a:p>
+            <a:pPr>
+              <a:buFont typeface="Wingdings" panose="05000000000000000000" pitchFamily="2" charset="2"/>
+              <a:buChar char="q"/>
+            </a:pPr>
+            <a:r>
+              <a:rPr lang="en-US" dirty="0">
+                <a:latin typeface="Garamond" panose="02020404030301010803" pitchFamily="18" charset="0"/>
+              </a:rPr>
+              <a:t>Minimize missed opportunities </a:t>
+            </a:r>
+            <a:br>
+              <a:rPr lang="en-US" dirty="0">
+                <a:latin typeface="Garamond" panose="02020404030301010803" pitchFamily="18" charset="0"/>
+              </a:rPr>
+            </a:br>
+            <a:endParaRPr lang="en-US" dirty="0">
+              <a:latin typeface="Garamond" panose="02020404030301010803" pitchFamily="18" charset="0"/>
+            </a:endParaRPr>
+          </a:p>
+          <a:p>
+            <a:pPr marL="0" indent="0">
+              <a:buNone/>
+            </a:pPr>
+            <a:r>
+              <a:rPr lang="en-US" b="1" dirty="0">
+                <a:latin typeface="Garamond" panose="02020404030301010803" pitchFamily="18" charset="0"/>
+              </a:rPr>
+              <a:t>Key Insight</a:t>
+            </a:r>
+          </a:p>
+          <a:p>
+            <a:pPr>
+              <a:buFont typeface="Wingdings" panose="05000000000000000000" pitchFamily="2" charset="2"/>
+              <a:buChar char="q"/>
+            </a:pPr>
+            <a:r>
+              <a:rPr lang="en-US" b="1" dirty="0">
+                <a:latin typeface="Garamond" panose="02020404030301010803" pitchFamily="18" charset="0"/>
+              </a:rPr>
+              <a:t>Better to reach more than to miss the willing</a:t>
+            </a:r>
+            <a:endParaRPr lang="en-US" dirty="0">
+              <a:latin typeface="Garamond" panose="02020404030301010803" pitchFamily="18" charset="0"/>
+            </a:endParaRPr>
+          </a:p>
+          <a:p>
+            <a:endParaRPr lang="en-US" dirty="0">
+              <a:latin typeface="Garamond" panose="02020404030301010803" pitchFamily="18" charset="0"/>
+            </a:endParaRPr>
+          </a:p>
+        </p:txBody>
+      </p:sp>
+    </p:spTree>
+    <p:extLst>
+      <p:ext uri="{BB962C8B-B14F-4D97-AF65-F5344CB8AC3E}">
+        <p14:creationId xmlns:p14="http://schemas.microsoft.com/office/powerpoint/2010/main" val="1588391361"/>
+      </p:ext>
+    </p:extLst>
+  </p:cSld>
+  <p:clrMapOvr>
+    <a:masterClrMapping/>
+  </p:clrMapOvr>
+</p:sld>
+</file>
+
+<file path=ppt/slides/slide11.xml><?xml version="1.0" encoding="utf-8"?>
+<p:sld xmlns:a="http://schemas.openxmlformats.org/drawingml/2006/main" xmlns:r="http://schemas.openxmlformats.org/officeDocument/2006/relationships" xmlns:p="http://schemas.openxmlformats.org/presentationml/2006/main">
+  <p:cSld>
+    <p:spTree>
+      <p:nvGrpSpPr>
+        <p:cNvPr id="1" name="">
+          <a:extLst>
+            <a:ext uri="{FF2B5EF4-FFF2-40B4-BE49-F238E27FC236}">
+              <a16:creationId xmlns:a16="http://schemas.microsoft.com/office/drawing/2014/main" id="{F389E7E5-F9F3-DC55-786F-24ED30F1E4F0}"/>
+            </a:ext>
+          </a:extLst>
+        </p:cNvPr>
+        <p:cNvGrpSpPr/>
+        <p:nvPr/>
+      </p:nvGrpSpPr>
+      <p:grpSpPr>
+        <a:xfrm>
+          <a:off x="0" y="0"/>
+          <a:ext cx="0" cy="0"/>
+          <a:chOff x="0" y="0"/>
+          <a:chExt cx="0" cy="0"/>
+        </a:xfrm>
+      </p:grpSpPr>
+      <p:sp>
+        <p:nvSpPr>
+          <p:cNvPr id="2" name="Title 1">
+            <a:extLst>
+              <a:ext uri="{FF2B5EF4-FFF2-40B4-BE49-F238E27FC236}">
+                <a16:creationId xmlns:a16="http://schemas.microsoft.com/office/drawing/2014/main" id="{B31E2171-BC38-1EF7-567C-C7D282A7A577}"/>
+              </a:ext>
+            </a:extLst>
+          </p:cNvPr>
+          <p:cNvSpPr>
+            <a:spLocks noGrp="1"/>
+          </p:cNvSpPr>
+          <p:nvPr>
+            <p:ph type="title"/>
+          </p:nvPr>
+        </p:nvSpPr>
+        <p:spPr>
+          <a:xfrm>
+            <a:off x="555585" y="567159"/>
+            <a:ext cx="8027043" cy="1928585"/>
+          </a:xfrm>
+        </p:spPr>
+        <p:txBody>
+          <a:bodyPr>
+            <a:noAutofit/>
+          </a:bodyPr>
+          <a:lstStyle/>
+          <a:p>
+            <a:r>
+              <a:rPr lang="en-US" sz="2800" b="1" dirty="0">
+                <a:latin typeface="Garamond" panose="02020404030301010803" pitchFamily="18" charset="0"/>
+              </a:rPr>
+              <a:t>Perception of Risk as a Vaccination Drive</a:t>
+            </a:r>
+            <a:br>
+              <a:rPr lang="en-US" sz="2800" b="1" dirty="0">
+                <a:latin typeface="Garamond" panose="02020404030301010803" pitchFamily="18" charset="0"/>
+              </a:rPr>
+            </a:br>
+            <a:r>
+              <a:rPr lang="en-US" sz="1600" dirty="0"/>
+              <a:t>The upward trend in the blue segments shows that while few who felt </a:t>
+            </a:r>
+            <a:r>
+              <a:rPr lang="en-US" sz="1600" b="1" dirty="0"/>
+              <a:t>Low Risk </a:t>
+            </a:r>
+            <a:r>
+              <a:rPr lang="en-US" sz="1600" dirty="0"/>
+              <a:t>got vaccinated, nearly half of those perceiving </a:t>
+            </a:r>
+            <a:r>
+              <a:rPr lang="en-US" sz="1600" b="1" dirty="0"/>
+              <a:t>Highest Risk </a:t>
+            </a:r>
+            <a:r>
+              <a:rPr lang="en-US" sz="1600" dirty="0"/>
+              <a:t>took action. </a:t>
+            </a:r>
+            <a:br>
+              <a:rPr lang="en-US" sz="3600" b="1" dirty="0">
+                <a:latin typeface="Garamond" panose="02020404030301010803" pitchFamily="18" charset="0"/>
+                <a:cs typeface="Archivo" pitchFamily="2" charset="0"/>
+              </a:rPr>
+            </a:br>
+            <a:endParaRPr lang="en-US" sz="2400" dirty="0">
+              <a:latin typeface="Garamond" panose="02020404030301010803" pitchFamily="18" charset="0"/>
+              <a:cs typeface="Archivo" pitchFamily="2" charset="0"/>
+            </a:endParaRPr>
+          </a:p>
+        </p:txBody>
+      </p:sp>
+      <p:pic>
+        <p:nvPicPr>
+          <p:cNvPr id="6" name="Content Placeholder 5">
+            <a:extLst>
+              <a:ext uri="{FF2B5EF4-FFF2-40B4-BE49-F238E27FC236}">
+                <a16:creationId xmlns:a16="http://schemas.microsoft.com/office/drawing/2014/main" id="{5B6C727D-26EA-7629-EC39-B85A9661A5A1}"/>
+              </a:ext>
+            </a:extLst>
+          </p:cNvPr>
+          <p:cNvPicPr>
+            <a:picLocks noGrp="1" noChangeAspect="1"/>
+          </p:cNvPicPr>
+          <p:nvPr>
+            <p:ph idx="1"/>
+          </p:nvPr>
+        </p:nvPicPr>
+        <p:blipFill>
+          <a:blip r:embed="rId3"/>
+          <a:stretch>
+            <a:fillRect/>
+          </a:stretch>
+        </p:blipFill>
+        <p:spPr>
+          <a:xfrm>
+            <a:off x="1039686" y="2495744"/>
+            <a:ext cx="7058839" cy="3339296"/>
+          </a:xfrm>
+        </p:spPr>
+      </p:pic>
+    </p:spTree>
+    <p:extLst>
+      <p:ext uri="{BB962C8B-B14F-4D97-AF65-F5344CB8AC3E}">
+        <p14:creationId xmlns:p14="http://schemas.microsoft.com/office/powerpoint/2010/main" val="3468541483"/>
+      </p:ext>
+    </p:extLst>
+  </p:cSld>
+  <p:clrMapOvr>
+    <a:masterClrMapping/>
+  </p:clrMapOvr>
+</p:sld>
+</file>
+
+<file path=ppt/slides/slide12.xml><?xml version="1.0" encoding="utf-8"?>
 <p:sld xmlns:a="http://schemas.openxmlformats.org/drawingml/2006/main" xmlns:r="http://schemas.openxmlformats.org/officeDocument/2006/relationships" xmlns:p="http://schemas.openxmlformats.org/presentationml/2006/main">
   <p:cSld>
     <p:spTree>
@@ -8161,7 +8771,13 @@
               <a:rPr lang="en-US" b="1" dirty="0">
                 <a:latin typeface="Garamond" panose="02020404030301010803" pitchFamily="18" charset="0"/>
               </a:rPr>
-              <a:t> The Strategy of Selection</a:t>
+              <a:t> </a:t>
+            </a:r>
+            <a:r>
+              <a:rPr lang="en-US" sz="3600" b="1" dirty="0">
+                <a:latin typeface="Garamond" panose="02020404030301010803" pitchFamily="18" charset="0"/>
+              </a:rPr>
+              <a:t>The Strategy of Selection</a:t>
             </a:r>
             <a:br>
               <a:rPr lang="en-US" b="1" dirty="0">
@@ -8169,7 +8785,7 @@
               </a:rPr>
             </a:br>
             <a:r>
-              <a:rPr lang="en-US" sz="2700" dirty="0">
+              <a:rPr lang="en-US" sz="2400" dirty="0">
                 <a:latin typeface="Garamond" panose="02020404030301010803" pitchFamily="18" charset="0"/>
               </a:rPr>
               <a:t>Choosing Coverage Over Precision</a:t>
@@ -8399,7 +9015,7 @@
 </p:sld>
 </file>
 
-<file path=ppt/slides/slide11.xml><?xml version="1.0" encoding="utf-8"?>
+<file path=ppt/slides/slide13.xml><?xml version="1.0" encoding="utf-8"?>
 <p:sld xmlns:a="http://schemas.openxmlformats.org/drawingml/2006/main" xmlns:r="http://schemas.openxmlformats.org/officeDocument/2006/relationships" xmlns:p="http://schemas.openxmlformats.org/presentationml/2006/main">
   <p:cSld>
     <p:spTree>
@@ -8463,15 +9079,7 @@
             </a:br>
             <a:r>
               <a:rPr lang="en-US" sz="1600" dirty="0"/>
-              <a:t>This heatmap serves as our </a:t>
-            </a:r>
-            <a:r>
-              <a:rPr lang="en-US" sz="1600" b="1" dirty="0"/>
-              <a:t>mathematical foundation</a:t>
-            </a:r>
-            <a:r>
-              <a:rPr lang="en-US" sz="1600" dirty="0"/>
-              <a:t> Notice the strong positive correlation between </a:t>
+              <a:t>Notice the strong positive correlation between </a:t>
             </a:r>
             <a:r>
               <a:rPr lang="en-US" sz="1600" b="1" dirty="0"/>
@@ -8487,15 +9095,7 @@
             </a:r>
             <a:r>
               <a:rPr lang="en-US" sz="1600" dirty="0"/>
-              <a:t>. This confirms that clinical intervention isn't just a minor factor—it is statistically </a:t>
-            </a:r>
-            <a:r>
-              <a:rPr lang="en-US" sz="1600" b="1" dirty="0"/>
-              <a:t>one of the most significant links</a:t>
-            </a:r>
-            <a:r>
-              <a:rPr lang="en-US" sz="1600" dirty="0"/>
-              <a:t> in our dataset.</a:t>
+              <a:t>. This confirms that clinical intervention isn't just a minor factor.</a:t>
             </a:r>
             <a:br>
               <a:rPr lang="en-US" sz="1600" dirty="0"/>
@@ -8549,7 +9149,7 @@
 </p:sld>
 </file>
 
-<file path=ppt/slides/slide12.xml><?xml version="1.0" encoding="utf-8"?>
+<file path=ppt/slides/slide14.xml><?xml version="1.0" encoding="utf-8"?>
 <p:sld xmlns:a="http://schemas.openxmlformats.org/drawingml/2006/main" xmlns:r="http://schemas.openxmlformats.org/officeDocument/2006/relationships" xmlns:p="http://schemas.openxmlformats.org/presentationml/2006/main">
   <p:cSld>
     <p:spTree>
@@ -8818,7 +9418,7 @@
 </p:sld>
 </file>
 
-<file path=ppt/slides/slide13.xml><?xml version="1.0" encoding="utf-8"?>
+<file path=ppt/slides/slide15.xml><?xml version="1.0" encoding="utf-8"?>
 <p:sld xmlns:a="http://schemas.openxmlformats.org/drawingml/2006/main" xmlns:r="http://schemas.openxmlformats.org/officeDocument/2006/relationships" xmlns:p="http://schemas.openxmlformats.org/presentationml/2006/main">
   <p:cSld>
     <p:spTree>
@@ -8920,10 +9520,10 @@
       </p:sp>
       <p:pic>
         <p:nvPicPr>
-          <p:cNvPr id="6" name="Content Placeholder 5">
+          <p:cNvPr id="7" name="Content Placeholder 6">
             <a:extLst>
               <a:ext uri="{FF2B5EF4-FFF2-40B4-BE49-F238E27FC236}">
-                <a16:creationId xmlns:a16="http://schemas.microsoft.com/office/drawing/2014/main" id="{7BB15E5C-E8E4-5B09-F234-08AC93460B8E}"/>
+                <a16:creationId xmlns:a16="http://schemas.microsoft.com/office/drawing/2014/main" id="{23F11209-F68E-4D98-43DD-F9FFE4A6BDD6}"/>
               </a:ext>
             </a:extLst>
           </p:cNvPr>
@@ -8942,8 +9542,8 @@
         </p:blipFill>
         <p:spPr>
           <a:xfrm>
-            <a:off x="902824" y="2419108"/>
-            <a:ext cx="7199453" cy="3646025"/>
+            <a:off x="1064871" y="2395959"/>
+            <a:ext cx="7292051" cy="3831221"/>
           </a:xfrm>
         </p:spPr>
       </p:pic>
@@ -8960,7 +9560,7 @@
 </p:sld>
 </file>
 
-<file path=ppt/slides/slide14.xml><?xml version="1.0" encoding="utf-8"?>
+<file path=ppt/slides/slide16.xml><?xml version="1.0" encoding="utf-8"?>
 <p:sld xmlns:a="http://schemas.openxmlformats.org/drawingml/2006/main" xmlns:r="http://schemas.openxmlformats.org/officeDocument/2006/relationships" xmlns:p="http://schemas.openxmlformats.org/presentationml/2006/main">
   <p:cSld>
     <p:spTree>
@@ -9210,7 +9810,7 @@
 </p:sld>
 </file>
 
-<file path=ppt/slides/slide15.xml><?xml version="1.0" encoding="utf-8"?>
+<file path=ppt/slides/slide17.xml><?xml version="1.0" encoding="utf-8"?>
 <p:sld xmlns:a="http://schemas.openxmlformats.org/drawingml/2006/main" xmlns:r="http://schemas.openxmlformats.org/officeDocument/2006/relationships" xmlns:p="http://schemas.openxmlformats.org/presentationml/2006/main">
   <p:cSld>
     <p:spTree>
@@ -9266,17 +9866,6 @@
                 <a:latin typeface="Garamond" panose="02020404030301010803" pitchFamily="18" charset="0"/>
               </a:rPr>
               <a:t>The 'Doctor Effect’</a:t>
-            </a:r>
-            <a:br>
-              <a:rPr lang="en-US" sz="3600" b="1" dirty="0">
-                <a:latin typeface="Garamond" panose="02020404030301010803" pitchFamily="18" charset="0"/>
-              </a:rPr>
-            </a:br>
-            <a:r>
-              <a:rPr lang="en-US" sz="1400" dirty="0">
-                <a:latin typeface="Garamond" panose="02020404030301010803" pitchFamily="18" charset="0"/>
-              </a:rPr>
-              <a:t>Impact of Recommendations on Compliance</a:t>
             </a:r>
             <a:br>
               <a:rPr lang="en-US" sz="1400" dirty="0">
@@ -9359,7 +9948,7 @@
 </p:sld>
 </file>
 
-<file path=ppt/slides/slide16.xml><?xml version="1.0" encoding="utf-8"?>
+<file path=ppt/slides/slide18.xml><?xml version="1.0" encoding="utf-8"?>
 <p:sld xmlns:a="http://schemas.openxmlformats.org/drawingml/2006/main" xmlns:r="http://schemas.openxmlformats.org/officeDocument/2006/relationships" xmlns:p="http://schemas.openxmlformats.org/presentationml/2006/main">
   <p:cSld>
     <p:spTree>
@@ -9622,7 +10211,7 @@
 </p:sld>
 </file>
 
-<file path=ppt/slides/slide17.xml><?xml version="1.0" encoding="utf-8"?>
+<file path=ppt/slides/slide19.xml><?xml version="1.0" encoding="utf-8"?>
 <p:sld xmlns:a="http://schemas.openxmlformats.org/drawingml/2006/main" xmlns:r="http://schemas.openxmlformats.org/officeDocument/2006/relationships" xmlns:p="http://schemas.openxmlformats.org/presentationml/2006/main">
   <p:cSld>
     <p:spTree>
@@ -9857,244 +10446,6 @@
     <p:extLst>
       <p:ext uri="{BB962C8B-B14F-4D97-AF65-F5344CB8AC3E}">
         <p14:creationId xmlns:p14="http://schemas.microsoft.com/office/powerpoint/2010/main" val="2334087169"/>
-      </p:ext>
-    </p:extLst>
-  </p:cSld>
-  <p:clrMapOvr>
-    <a:masterClrMapping/>
-  </p:clrMapOvr>
-</p:sld>
-</file>
-
-<file path=ppt/slides/slide18.xml><?xml version="1.0" encoding="utf-8"?>
-<p:sld xmlns:a="http://schemas.openxmlformats.org/drawingml/2006/main" xmlns:r="http://schemas.openxmlformats.org/officeDocument/2006/relationships" xmlns:p="http://schemas.openxmlformats.org/presentationml/2006/main">
-  <p:cSld>
-    <p:spTree>
-      <p:nvGrpSpPr>
-        <p:cNvPr id="1" name="">
-          <a:extLst>
-            <a:ext uri="{FF2B5EF4-FFF2-40B4-BE49-F238E27FC236}">
-              <a16:creationId xmlns:a16="http://schemas.microsoft.com/office/drawing/2014/main" id="{9A04C5A6-AE39-8E74-EDFD-4BF63B6E3C04}"/>
-            </a:ext>
-          </a:extLst>
-        </p:cNvPr>
-        <p:cNvGrpSpPr/>
-        <p:nvPr/>
-      </p:nvGrpSpPr>
-      <p:grpSpPr>
-        <a:xfrm>
-          <a:off x="0" y="0"/>
-          <a:ext cx="0" cy="0"/>
-          <a:chOff x="0" y="0"/>
-          <a:chExt cx="0" cy="0"/>
-        </a:xfrm>
-      </p:grpSpPr>
-      <p:sp>
-        <p:nvSpPr>
-          <p:cNvPr id="2" name="Title 1">
-            <a:extLst>
-              <a:ext uri="{FF2B5EF4-FFF2-40B4-BE49-F238E27FC236}">
-                <a16:creationId xmlns:a16="http://schemas.microsoft.com/office/drawing/2014/main" id="{DC595B07-7566-B5D5-3932-9E669B8CC59E}"/>
-              </a:ext>
-            </a:extLst>
-          </p:cNvPr>
-          <p:cNvSpPr>
-            <a:spLocks noGrp="1"/>
-          </p:cNvSpPr>
-          <p:nvPr>
-            <p:ph type="title"/>
-          </p:nvPr>
-        </p:nvSpPr>
-        <p:spPr/>
-        <p:txBody>
-          <a:bodyPr>
-            <a:normAutofit/>
-          </a:bodyPr>
-          <a:lstStyle/>
-          <a:p>
-            <a:r>
-              <a:rPr lang="en-US" b="1" dirty="0">
-                <a:latin typeface="Garamond" panose="02020404030301010803" pitchFamily="18" charset="0"/>
-              </a:rPr>
-              <a:t>Dialogue</a:t>
-            </a:r>
-            <a:br>
-              <a:rPr lang="en-US" b="1" dirty="0">
-                <a:latin typeface="Garamond" panose="02020404030301010803" pitchFamily="18" charset="0"/>
-              </a:rPr>
-            </a:br>
-            <a:r>
-              <a:rPr lang="en-US" sz="2700" dirty="0">
-                <a:latin typeface="Garamond" panose="02020404030301010803" pitchFamily="18" charset="0"/>
-              </a:rPr>
-              <a:t>Bridging Data &amp; Strategy</a:t>
-            </a:r>
-          </a:p>
-        </p:txBody>
-      </p:sp>
-      <p:sp>
-        <p:nvSpPr>
-          <p:cNvPr id="3" name="Content Placeholder 2">
-            <a:extLst>
-              <a:ext uri="{FF2B5EF4-FFF2-40B4-BE49-F238E27FC236}">
-                <a16:creationId xmlns:a16="http://schemas.microsoft.com/office/drawing/2014/main" id="{35D8E8E1-BA9F-2A79-3399-389E119AFBBA}"/>
-              </a:ext>
-            </a:extLst>
-          </p:cNvPr>
-          <p:cNvSpPr>
-            <a:spLocks noGrp="1"/>
-          </p:cNvSpPr>
-          <p:nvPr>
-            <p:ph idx="1"/>
-          </p:nvPr>
-        </p:nvSpPr>
-        <p:spPr/>
-        <p:txBody>
-          <a:bodyPr>
-            <a:normAutofit fontScale="62500" lnSpcReduction="20000"/>
-          </a:bodyPr>
-          <a:lstStyle/>
-          <a:p>
-            <a:pPr marL="0" indent="0">
-              <a:buNone/>
-            </a:pPr>
-            <a:r>
-              <a:rPr lang="en-US" b="1" dirty="0">
-                <a:latin typeface="Garamond" panose="02020404030301010803" pitchFamily="18" charset="0"/>
-              </a:rPr>
-              <a:t>Quick Summary</a:t>
-            </a:r>
-            <a:endParaRPr lang="en-US" dirty="0">
-              <a:latin typeface="Garamond" panose="02020404030301010803" pitchFamily="18" charset="0"/>
-            </a:endParaRPr>
-          </a:p>
-          <a:p>
-            <a:pPr>
-              <a:buFont typeface="Wingdings" panose="05000000000000000000" pitchFamily="2" charset="2"/>
-              <a:buChar char="q"/>
-            </a:pPr>
-            <a:r>
-              <a:rPr lang="en-US" sz="2600" b="1" dirty="0">
-                <a:latin typeface="Garamond" panose="02020404030301010803" pitchFamily="18" charset="0"/>
-              </a:rPr>
-              <a:t>Model: </a:t>
-            </a:r>
-            <a:r>
-              <a:rPr lang="en-US" sz="2600" dirty="0">
-                <a:latin typeface="Garamond" panose="02020404030301010803" pitchFamily="18" charset="0"/>
-              </a:rPr>
-              <a:t>High-recall Logistic Regression maximizes community coverage</a:t>
-            </a:r>
-          </a:p>
-          <a:p>
-            <a:pPr>
-              <a:buFont typeface="Wingdings" panose="05000000000000000000" pitchFamily="2" charset="2"/>
-              <a:buChar char="q"/>
-            </a:pPr>
-            <a:r>
-              <a:rPr lang="en-US" sz="2600" b="1" dirty="0">
-                <a:latin typeface="Garamond" panose="02020404030301010803" pitchFamily="18" charset="0"/>
-              </a:rPr>
-              <a:t>Insight: </a:t>
-            </a:r>
-            <a:r>
-              <a:rPr lang="en-US" sz="2600" dirty="0">
-                <a:latin typeface="Garamond" panose="02020404030301010803" pitchFamily="18" charset="0"/>
-              </a:rPr>
-              <a:t>Trust outweighs habits in driving vaccination.</a:t>
-            </a:r>
-          </a:p>
-          <a:p>
-            <a:pPr>
-              <a:buFont typeface="Wingdings" panose="05000000000000000000" pitchFamily="2" charset="2"/>
-              <a:buChar char="q"/>
-            </a:pPr>
-            <a:r>
-              <a:rPr lang="en-US" sz="2600" b="1" dirty="0">
-                <a:latin typeface="Garamond" panose="02020404030301010803" pitchFamily="18" charset="0"/>
-              </a:rPr>
-              <a:t>Strategy: </a:t>
-            </a:r>
-            <a:r>
-              <a:rPr lang="en-US" sz="2600" dirty="0">
-                <a:latin typeface="Garamond" panose="02020404030301010803" pitchFamily="18" charset="0"/>
-              </a:rPr>
-              <a:t>Clear, targeted communication to close information Gap.</a:t>
-            </a:r>
-          </a:p>
-          <a:p>
-            <a:pPr marL="0" lvl="0" indent="0">
-              <a:buNone/>
-            </a:pPr>
-            <a:endParaRPr lang="en-US" dirty="0">
-              <a:latin typeface="Garamond" panose="02020404030301010803" pitchFamily="18" charset="0"/>
-            </a:endParaRPr>
-          </a:p>
-          <a:p>
-            <a:pPr marL="0" indent="0">
-              <a:buNone/>
-            </a:pPr>
-            <a:r>
-              <a:rPr lang="en-US" b="1" dirty="0">
-                <a:latin typeface="Garamond" panose="02020404030301010803" pitchFamily="18" charset="0"/>
-              </a:rPr>
-              <a:t>Discussion</a:t>
-            </a:r>
-          </a:p>
-          <a:p>
-            <a:pPr marL="0" indent="0">
-              <a:buNone/>
-            </a:pPr>
-            <a:r>
-              <a:rPr lang="en-US" sz="2600" dirty="0">
-                <a:latin typeface="Garamond" panose="02020404030301010803" pitchFamily="18" charset="0"/>
-              </a:rPr>
-              <a:t>welcome your technical inquiries, strategic critiques, or thoughts on how we can better map the 'Trust Threshold' for the next global health challenge.</a:t>
-            </a:r>
-          </a:p>
-          <a:p>
-            <a:pPr marL="0" indent="0">
-              <a:buNone/>
-            </a:pPr>
-            <a:endParaRPr lang="en-US" i="1" dirty="0">
-              <a:latin typeface="Garamond" panose="02020404030301010803" pitchFamily="18" charset="0"/>
-            </a:endParaRPr>
-          </a:p>
-          <a:p>
-            <a:pPr marL="0" indent="0">
-              <a:buNone/>
-            </a:pPr>
-            <a:r>
-              <a:rPr lang="en-US" sz="2000" b="1" dirty="0">
-                <a:latin typeface="Garamond" panose="02020404030301010803" pitchFamily="18" charset="0"/>
-              </a:rPr>
-              <a:t>For Q&amp;A, Inbox me at </a:t>
-            </a:r>
-            <a:r>
-              <a:rPr lang="en-US" sz="2000" b="1" dirty="0">
-                <a:latin typeface="Garamond" panose="02020404030301010803" pitchFamily="18" charset="0"/>
-                <a:hlinkClick r:id="rId3"/>
-              </a:rPr>
-              <a:t>garangabel262@gmail.com</a:t>
-            </a:r>
-            <a:r>
-              <a:rPr lang="en-US" sz="2000" b="1" dirty="0">
-                <a:latin typeface="Garamond" panose="02020404030301010803" pitchFamily="18" charset="0"/>
-              </a:rPr>
-              <a:t>. I will get to you within 24 hours.</a:t>
-            </a:r>
-          </a:p>
-          <a:p>
-            <a:endParaRPr lang="en-US" dirty="0">
-              <a:latin typeface="Garamond" panose="02020404030301010803" pitchFamily="18" charset="0"/>
-            </a:endParaRPr>
-          </a:p>
-        </p:txBody>
-      </p:sp>
-    </p:spTree>
-    <p:extLst>
-      <p:ext uri="{BB962C8B-B14F-4D97-AF65-F5344CB8AC3E}">
-        <p14:creationId xmlns:p14="http://schemas.microsoft.com/office/powerpoint/2010/main" val="195999001"/>
       </p:ext>
     </p:extLst>
   </p:cSld>
@@ -10156,7 +10507,7 @@
           <a:lstStyle/>
           <a:p>
             <a:r>
-              <a:rPr lang="en-US" sz="3600" b="1" dirty="0">
+              <a:rPr lang="en-US" sz="3200" b="1" dirty="0">
                 <a:latin typeface="Garamond" panose="02020404030301010803" pitchFamily="18" charset="0"/>
               </a:rPr>
               <a:t>The Data Blueprint &amp; Strategic Gap</a:t>
@@ -10455,7 +10806,481 @@
 </p:sld>
 </file>
 
+<file path=ppt/slides/slide20.xml><?xml version="1.0" encoding="utf-8"?>
+<p:sld xmlns:a="http://schemas.openxmlformats.org/drawingml/2006/main" xmlns:r="http://schemas.openxmlformats.org/officeDocument/2006/relationships" xmlns:p="http://schemas.openxmlformats.org/presentationml/2006/main">
+  <p:cSld>
+    <p:spTree>
+      <p:nvGrpSpPr>
+        <p:cNvPr id="1" name="">
+          <a:extLst>
+            <a:ext uri="{FF2B5EF4-FFF2-40B4-BE49-F238E27FC236}">
+              <a16:creationId xmlns:a16="http://schemas.microsoft.com/office/drawing/2014/main" id="{9A04C5A6-AE39-8E74-EDFD-4BF63B6E3C04}"/>
+            </a:ext>
+          </a:extLst>
+        </p:cNvPr>
+        <p:cNvGrpSpPr/>
+        <p:nvPr/>
+      </p:nvGrpSpPr>
+      <p:grpSpPr>
+        <a:xfrm>
+          <a:off x="0" y="0"/>
+          <a:ext cx="0" cy="0"/>
+          <a:chOff x="0" y="0"/>
+          <a:chExt cx="0" cy="0"/>
+        </a:xfrm>
+      </p:grpSpPr>
+      <p:sp>
+        <p:nvSpPr>
+          <p:cNvPr id="2" name="Title 1">
+            <a:extLst>
+              <a:ext uri="{FF2B5EF4-FFF2-40B4-BE49-F238E27FC236}">
+                <a16:creationId xmlns:a16="http://schemas.microsoft.com/office/drawing/2014/main" id="{DC595B07-7566-B5D5-3932-9E669B8CC59E}"/>
+              </a:ext>
+            </a:extLst>
+          </p:cNvPr>
+          <p:cNvSpPr>
+            <a:spLocks noGrp="1"/>
+          </p:cNvSpPr>
+          <p:nvPr>
+            <p:ph type="title"/>
+          </p:nvPr>
+        </p:nvSpPr>
+        <p:spPr/>
+        <p:txBody>
+          <a:bodyPr>
+            <a:normAutofit/>
+          </a:bodyPr>
+          <a:lstStyle/>
+          <a:p>
+            <a:r>
+              <a:rPr lang="en-US" b="1" dirty="0">
+                <a:latin typeface="Garamond" panose="02020404030301010803" pitchFamily="18" charset="0"/>
+              </a:rPr>
+              <a:t>Dialogue</a:t>
+            </a:r>
+            <a:br>
+              <a:rPr lang="en-US" b="1" dirty="0">
+                <a:latin typeface="Garamond" panose="02020404030301010803" pitchFamily="18" charset="0"/>
+              </a:rPr>
+            </a:br>
+            <a:r>
+              <a:rPr lang="en-US" sz="2700" dirty="0">
+                <a:latin typeface="Garamond" panose="02020404030301010803" pitchFamily="18" charset="0"/>
+              </a:rPr>
+              <a:t>Bridging Data &amp; Strategy</a:t>
+            </a:r>
+          </a:p>
+        </p:txBody>
+      </p:sp>
+      <p:sp>
+        <p:nvSpPr>
+          <p:cNvPr id="3" name="Content Placeholder 2">
+            <a:extLst>
+              <a:ext uri="{FF2B5EF4-FFF2-40B4-BE49-F238E27FC236}">
+                <a16:creationId xmlns:a16="http://schemas.microsoft.com/office/drawing/2014/main" id="{35D8E8E1-BA9F-2A79-3399-389E119AFBBA}"/>
+              </a:ext>
+            </a:extLst>
+          </p:cNvPr>
+          <p:cNvSpPr>
+            <a:spLocks noGrp="1"/>
+          </p:cNvSpPr>
+          <p:nvPr>
+            <p:ph idx="1"/>
+          </p:nvPr>
+        </p:nvSpPr>
+        <p:spPr/>
+        <p:txBody>
+          <a:bodyPr>
+            <a:normAutofit fontScale="62500" lnSpcReduction="20000"/>
+          </a:bodyPr>
+          <a:lstStyle/>
+          <a:p>
+            <a:pPr marL="0" indent="0">
+              <a:buNone/>
+            </a:pPr>
+            <a:r>
+              <a:rPr lang="en-US" b="1" dirty="0">
+                <a:latin typeface="Garamond" panose="02020404030301010803" pitchFamily="18" charset="0"/>
+              </a:rPr>
+              <a:t>Quick Summary</a:t>
+            </a:r>
+            <a:endParaRPr lang="en-US" dirty="0">
+              <a:latin typeface="Garamond" panose="02020404030301010803" pitchFamily="18" charset="0"/>
+            </a:endParaRPr>
+          </a:p>
+          <a:p>
+            <a:pPr>
+              <a:buFont typeface="Wingdings" panose="05000000000000000000" pitchFamily="2" charset="2"/>
+              <a:buChar char="q"/>
+            </a:pPr>
+            <a:r>
+              <a:rPr lang="en-US" sz="2600" b="1" dirty="0">
+                <a:latin typeface="Garamond" panose="02020404030301010803" pitchFamily="18" charset="0"/>
+              </a:rPr>
+              <a:t>Model: </a:t>
+            </a:r>
+            <a:r>
+              <a:rPr lang="en-US" sz="2600" dirty="0">
+                <a:latin typeface="Garamond" panose="02020404030301010803" pitchFamily="18" charset="0"/>
+              </a:rPr>
+              <a:t>High-recall Logistic Regression maximizes community coverage</a:t>
+            </a:r>
+          </a:p>
+          <a:p>
+            <a:pPr>
+              <a:buFont typeface="Wingdings" panose="05000000000000000000" pitchFamily="2" charset="2"/>
+              <a:buChar char="q"/>
+            </a:pPr>
+            <a:r>
+              <a:rPr lang="en-US" sz="2600" b="1" dirty="0">
+                <a:latin typeface="Garamond" panose="02020404030301010803" pitchFamily="18" charset="0"/>
+              </a:rPr>
+              <a:t>Insight: </a:t>
+            </a:r>
+            <a:r>
+              <a:rPr lang="en-US" sz="2600" dirty="0">
+                <a:latin typeface="Garamond" panose="02020404030301010803" pitchFamily="18" charset="0"/>
+              </a:rPr>
+              <a:t>Trust outweighs habits in driving vaccination.</a:t>
+            </a:r>
+          </a:p>
+          <a:p>
+            <a:pPr>
+              <a:buFont typeface="Wingdings" panose="05000000000000000000" pitchFamily="2" charset="2"/>
+              <a:buChar char="q"/>
+            </a:pPr>
+            <a:r>
+              <a:rPr lang="en-US" sz="2600" b="1" dirty="0">
+                <a:latin typeface="Garamond" panose="02020404030301010803" pitchFamily="18" charset="0"/>
+              </a:rPr>
+              <a:t>Strategy: </a:t>
+            </a:r>
+            <a:r>
+              <a:rPr lang="en-US" sz="2600" dirty="0">
+                <a:latin typeface="Garamond" panose="02020404030301010803" pitchFamily="18" charset="0"/>
+              </a:rPr>
+              <a:t>Clear, targeted communication to close information Gap.</a:t>
+            </a:r>
+          </a:p>
+          <a:p>
+            <a:pPr marL="0" lvl="0" indent="0">
+              <a:buNone/>
+            </a:pPr>
+            <a:endParaRPr lang="en-US" dirty="0">
+              <a:latin typeface="Garamond" panose="02020404030301010803" pitchFamily="18" charset="0"/>
+            </a:endParaRPr>
+          </a:p>
+          <a:p>
+            <a:pPr marL="0" indent="0">
+              <a:buNone/>
+            </a:pPr>
+            <a:r>
+              <a:rPr lang="en-US" b="1" dirty="0">
+                <a:latin typeface="Garamond" panose="02020404030301010803" pitchFamily="18" charset="0"/>
+              </a:rPr>
+              <a:t>Discussion</a:t>
+            </a:r>
+          </a:p>
+          <a:p>
+            <a:pPr marL="0" indent="0">
+              <a:buNone/>
+            </a:pPr>
+            <a:r>
+              <a:rPr lang="en-US" sz="2600" dirty="0">
+                <a:latin typeface="Garamond" panose="02020404030301010803" pitchFamily="18" charset="0"/>
+              </a:rPr>
+              <a:t>welcome your technical inquiries, strategic critiques, or thoughts on how we can better map the 'Trust Threshold' for the next global health challenge.</a:t>
+            </a:r>
+          </a:p>
+          <a:p>
+            <a:pPr marL="0" indent="0">
+              <a:buNone/>
+            </a:pPr>
+            <a:endParaRPr lang="en-US" i="1" dirty="0">
+              <a:latin typeface="Garamond" panose="02020404030301010803" pitchFamily="18" charset="0"/>
+            </a:endParaRPr>
+          </a:p>
+          <a:p>
+            <a:pPr marL="0" indent="0">
+              <a:buNone/>
+            </a:pPr>
+            <a:r>
+              <a:rPr lang="en-US" sz="2900" b="1" dirty="0">
+                <a:latin typeface="Garamond" panose="02020404030301010803" pitchFamily="18" charset="0"/>
+              </a:rPr>
+              <a:t>For Questions</a:t>
+            </a:r>
+            <a:r>
+              <a:rPr lang="en-US" sz="2000" b="1" dirty="0">
+                <a:latin typeface="Garamond" panose="02020404030301010803" pitchFamily="18" charset="0"/>
+              </a:rPr>
+              <a:t>, Inbox me at </a:t>
+            </a:r>
+            <a:r>
+              <a:rPr lang="en-US" sz="2000" b="1" dirty="0">
+                <a:latin typeface="Garamond" panose="02020404030301010803" pitchFamily="18" charset="0"/>
+                <a:hlinkClick r:id="rId3"/>
+              </a:rPr>
+              <a:t>garangabel262@gmail.com</a:t>
+            </a:r>
+            <a:r>
+              <a:rPr lang="en-US" sz="2000" b="1" dirty="0">
+                <a:latin typeface="Garamond" panose="02020404030301010803" pitchFamily="18" charset="0"/>
+              </a:rPr>
+              <a:t>. I will get to you within 24 hours.</a:t>
+            </a:r>
+          </a:p>
+          <a:p>
+            <a:endParaRPr lang="en-US" dirty="0">
+              <a:latin typeface="Garamond" panose="02020404030301010803" pitchFamily="18" charset="0"/>
+            </a:endParaRPr>
+          </a:p>
+        </p:txBody>
+      </p:sp>
+    </p:spTree>
+    <p:extLst>
+      <p:ext uri="{BB962C8B-B14F-4D97-AF65-F5344CB8AC3E}">
+        <p14:creationId xmlns:p14="http://schemas.microsoft.com/office/powerpoint/2010/main" val="195999001"/>
+      </p:ext>
+    </p:extLst>
+  </p:cSld>
+  <p:clrMapOvr>
+    <a:masterClrMapping/>
+  </p:clrMapOvr>
+</p:sld>
+</file>
+
 <file path=ppt/slides/slide3.xml><?xml version="1.0" encoding="utf-8"?>
+<p:sld xmlns:a="http://schemas.openxmlformats.org/drawingml/2006/main" xmlns:r="http://schemas.openxmlformats.org/officeDocument/2006/relationships" xmlns:p="http://schemas.openxmlformats.org/presentationml/2006/main">
+  <p:cSld>
+    <p:spTree>
+      <p:nvGrpSpPr>
+        <p:cNvPr id="1" name="">
+          <a:extLst>
+            <a:ext uri="{FF2B5EF4-FFF2-40B4-BE49-F238E27FC236}">
+              <a16:creationId xmlns:a16="http://schemas.microsoft.com/office/drawing/2014/main" id="{9655384B-C2A1-7CB1-A433-67992DCB46AC}"/>
+            </a:ext>
+          </a:extLst>
+        </p:cNvPr>
+        <p:cNvGrpSpPr/>
+        <p:nvPr/>
+      </p:nvGrpSpPr>
+      <p:grpSpPr>
+        <a:xfrm>
+          <a:off x="0" y="0"/>
+          <a:ext cx="0" cy="0"/>
+          <a:chOff x="0" y="0"/>
+          <a:chExt cx="0" cy="0"/>
+        </a:xfrm>
+      </p:grpSpPr>
+      <p:sp>
+        <p:nvSpPr>
+          <p:cNvPr id="2" name="Title 1">
+            <a:extLst>
+              <a:ext uri="{FF2B5EF4-FFF2-40B4-BE49-F238E27FC236}">
+                <a16:creationId xmlns:a16="http://schemas.microsoft.com/office/drawing/2014/main" id="{F230270F-2E88-9591-D82F-B55084D944D8}"/>
+              </a:ext>
+            </a:extLst>
+          </p:cNvPr>
+          <p:cNvSpPr>
+            <a:spLocks noGrp="1"/>
+          </p:cNvSpPr>
+          <p:nvPr>
+            <p:ph type="title"/>
+          </p:nvPr>
+        </p:nvSpPr>
+        <p:spPr>
+          <a:xfrm>
+            <a:off x="353028" y="830221"/>
+            <a:ext cx="8229600" cy="1143000"/>
+          </a:xfrm>
+        </p:spPr>
+        <p:txBody>
+          <a:bodyPr>
+            <a:noAutofit/>
+          </a:bodyPr>
+          <a:lstStyle/>
+          <a:p>
+            <a:r>
+              <a:rPr lang="en-US" sz="3600" b="1" dirty="0">
+                <a:latin typeface="Garamond" panose="02020404030301010803" pitchFamily="18" charset="0"/>
+              </a:rPr>
+              <a:t>Decision tree Model</a:t>
+            </a:r>
+            <a:endParaRPr lang="en-US" sz="2400" dirty="0">
+              <a:latin typeface="Garamond" panose="02020404030301010803" pitchFamily="18" charset="0"/>
+            </a:endParaRPr>
+          </a:p>
+        </p:txBody>
+      </p:sp>
+      <p:pic>
+        <p:nvPicPr>
+          <p:cNvPr id="5" name="Content Placeholder 4">
+            <a:extLst>
+              <a:ext uri="{FF2B5EF4-FFF2-40B4-BE49-F238E27FC236}">
+                <a16:creationId xmlns:a16="http://schemas.microsoft.com/office/drawing/2014/main" id="{8352BAB4-3E52-D710-F6D6-9BC3A5DE7A60}"/>
+              </a:ext>
+            </a:extLst>
+          </p:cNvPr>
+          <p:cNvPicPr>
+            <a:picLocks noGrp="1" noChangeAspect="1"/>
+          </p:cNvPicPr>
+          <p:nvPr>
+            <p:ph idx="1"/>
+          </p:nvPr>
+        </p:nvPicPr>
+        <p:blipFill>
+          <a:blip r:embed="rId3"/>
+          <a:stretch>
+            <a:fillRect/>
+          </a:stretch>
+        </p:blipFill>
+        <p:spPr>
+          <a:xfrm>
+            <a:off x="1296988" y="2395959"/>
+            <a:ext cx="6724650" cy="3630911"/>
+          </a:xfrm>
+        </p:spPr>
+      </p:pic>
+    </p:spTree>
+    <p:extLst>
+      <p:ext uri="{BB962C8B-B14F-4D97-AF65-F5344CB8AC3E}">
+        <p14:creationId xmlns:p14="http://schemas.microsoft.com/office/powerpoint/2010/main" val="1638637632"/>
+      </p:ext>
+    </p:extLst>
+  </p:cSld>
+  <p:clrMapOvr>
+    <a:masterClrMapping/>
+  </p:clrMapOvr>
+</p:sld>
+</file>
+
+<file path=ppt/slides/slide4.xml><?xml version="1.0" encoding="utf-8"?>
+<p:sld xmlns:a="http://schemas.openxmlformats.org/drawingml/2006/main" xmlns:r="http://schemas.openxmlformats.org/officeDocument/2006/relationships" xmlns:p="http://schemas.openxmlformats.org/presentationml/2006/main">
+  <p:cSld>
+    <p:spTree>
+      <p:nvGrpSpPr>
+        <p:cNvPr id="1" name="">
+          <a:extLst>
+            <a:ext uri="{FF2B5EF4-FFF2-40B4-BE49-F238E27FC236}">
+              <a16:creationId xmlns:a16="http://schemas.microsoft.com/office/drawing/2014/main" id="{CBFDDDAD-C9AE-1ACA-3C2C-9BB8580A2D62}"/>
+            </a:ext>
+          </a:extLst>
+        </p:cNvPr>
+        <p:cNvGrpSpPr/>
+        <p:nvPr/>
+      </p:nvGrpSpPr>
+      <p:grpSpPr>
+        <a:xfrm>
+          <a:off x="0" y="0"/>
+          <a:ext cx="0" cy="0"/>
+          <a:chOff x="0" y="0"/>
+          <a:chExt cx="0" cy="0"/>
+        </a:xfrm>
+      </p:grpSpPr>
+      <p:sp>
+        <p:nvSpPr>
+          <p:cNvPr id="2" name="Title 1">
+            <a:extLst>
+              <a:ext uri="{FF2B5EF4-FFF2-40B4-BE49-F238E27FC236}">
+                <a16:creationId xmlns:a16="http://schemas.microsoft.com/office/drawing/2014/main" id="{C94A876E-17A1-08CE-F2C1-758B84C9BF37}"/>
+              </a:ext>
+            </a:extLst>
+          </p:cNvPr>
+          <p:cNvSpPr>
+            <a:spLocks noGrp="1"/>
+          </p:cNvSpPr>
+          <p:nvPr>
+            <p:ph type="title"/>
+          </p:nvPr>
+        </p:nvSpPr>
+        <p:spPr>
+          <a:xfrm>
+            <a:off x="353028" y="830221"/>
+            <a:ext cx="8229600" cy="1357394"/>
+          </a:xfrm>
+        </p:spPr>
+        <p:txBody>
+          <a:bodyPr>
+            <a:noAutofit/>
+          </a:bodyPr>
+          <a:lstStyle/>
+          <a:p>
+            <a:r>
+              <a:rPr lang="en-US" sz="3600" b="1" dirty="0">
+                <a:latin typeface="Garamond" panose="02020404030301010803" pitchFamily="18" charset="0"/>
+              </a:rPr>
+              <a:t>Random Forest Model </a:t>
+            </a:r>
+            <a:br>
+              <a:rPr lang="en-US" sz="3600" b="1" dirty="0">
+                <a:latin typeface="Garamond" panose="02020404030301010803" pitchFamily="18" charset="0"/>
+              </a:rPr>
+            </a:br>
+            <a:r>
+              <a:rPr lang="en-US" sz="2400" dirty="0"/>
+              <a:t> </a:t>
+            </a:r>
+            <a:r>
+              <a:rPr lang="en-US" sz="2400" dirty="0">
+                <a:latin typeface="Garamond" panose="02020404030301010803" pitchFamily="18" charset="0"/>
+              </a:rPr>
+              <a:t>Perception vs. Reality</a:t>
+            </a:r>
+            <a:br>
+              <a:rPr lang="en-US" sz="2400" dirty="0">
+                <a:latin typeface="Garamond" panose="02020404030301010803" pitchFamily="18" charset="0"/>
+              </a:rPr>
+            </a:br>
+            <a:endParaRPr lang="en-US" sz="2400" dirty="0">
+              <a:latin typeface="Garamond" panose="02020404030301010803" pitchFamily="18" charset="0"/>
+            </a:endParaRPr>
+          </a:p>
+        </p:txBody>
+      </p:sp>
+      <p:pic>
+        <p:nvPicPr>
+          <p:cNvPr id="5" name="Content Placeholder 4">
+            <a:extLst>
+              <a:ext uri="{FF2B5EF4-FFF2-40B4-BE49-F238E27FC236}">
+                <a16:creationId xmlns:a16="http://schemas.microsoft.com/office/drawing/2014/main" id="{8A94384F-AC7A-4489-EB38-1CBBE7B5159D}"/>
+              </a:ext>
+            </a:extLst>
+          </p:cNvPr>
+          <p:cNvPicPr>
+            <a:picLocks noGrp="1" noChangeAspect="1"/>
+          </p:cNvPicPr>
+          <p:nvPr>
+            <p:ph idx="1"/>
+          </p:nvPr>
+        </p:nvPicPr>
+        <p:blipFill>
+          <a:blip r:embed="rId3"/>
+          <a:stretch>
+            <a:fillRect/>
+          </a:stretch>
+        </p:blipFill>
+        <p:spPr>
+          <a:xfrm>
+            <a:off x="1296988" y="2407535"/>
+            <a:ext cx="6724650" cy="3645178"/>
+          </a:xfrm>
+        </p:spPr>
+      </p:pic>
+    </p:spTree>
+    <p:extLst>
+      <p:ext uri="{BB962C8B-B14F-4D97-AF65-F5344CB8AC3E}">
+        <p14:creationId xmlns:p14="http://schemas.microsoft.com/office/powerpoint/2010/main" val="4178219387"/>
+      </p:ext>
+    </p:extLst>
+  </p:cSld>
+  <p:clrMapOvr>
+    <a:masterClrMapping/>
+  </p:clrMapOvr>
+</p:sld>
+</file>
+
+<file path=ppt/slides/slide5.xml><?xml version="1.0" encoding="utf-8"?>
 <p:sld xmlns:a="http://schemas.openxmlformats.org/drawingml/2006/main" xmlns:r="http://schemas.openxmlformats.org/officeDocument/2006/relationships" xmlns:p="http://schemas.openxmlformats.org/presentationml/2006/main">
   <p:cSld>
     <p:spTree>
@@ -10518,31 +11343,14 @@
               </a:rPr>
             </a:br>
             <a:r>
-              <a:rPr lang="en-US" sz="2400" dirty="0"/>
-              <a:t> </a:t>
-            </a:r>
-            <a:r>
-              <a:rPr lang="en-US" sz="2400" dirty="0">
-                <a:latin typeface="Garamond" panose="02020404030301010803" pitchFamily="18" charset="0"/>
-              </a:rPr>
-              <a:t>Perception vs. Reality</a:t>
-            </a:r>
-            <a:br>
-              <a:rPr lang="en-US" sz="2400" dirty="0">
-                <a:latin typeface="Garamond" panose="02020404030301010803" pitchFamily="18" charset="0"/>
-              </a:rPr>
-            </a:br>
+              <a:rPr lang="en-US" sz="1600" dirty="0">
+                <a:latin typeface="Garamond" panose="02020404030301010803" pitchFamily="18" charset="0"/>
+              </a:rPr>
+              <a:t>T</a:t>
+            </a:r>
             <a:r>
               <a:rPr lang="en-US" sz="1600" dirty="0"/>
-              <a:t>Out of 30+ variables analyzed, these </a:t>
-            </a:r>
-            <a:r>
-              <a:rPr lang="en-US" sz="1600" b="1" dirty="0"/>
-              <a:t>15 represent the Vitals </a:t>
-            </a:r>
-            <a:r>
-              <a:rPr lang="en-US" sz="1600" dirty="0"/>
-              <a:t>the most influential factors driving an individual’s decision to get vaccinated.</a:t>
+              <a:t>he most influential factors driving an individual’s decision to get vaccinated.</a:t>
             </a:r>
             <a:br>
               <a:rPr lang="en-US" sz="1600" dirty="0"/>
@@ -10602,7 +11410,7 @@
 </p:sld>
 </file>
 
-<file path=ppt/slides/slide4.xml><?xml version="1.0" encoding="utf-8"?>
+<file path=ppt/slides/slide6.xml><?xml version="1.0" encoding="utf-8"?>
 <p:sld xmlns:a="http://schemas.openxmlformats.org/drawingml/2006/main" xmlns:r="http://schemas.openxmlformats.org/officeDocument/2006/relationships" xmlns:p="http://schemas.openxmlformats.org/presentationml/2006/main">
   <p:cSld>
     <p:spTree>
@@ -11016,7 +11824,7 @@
 </p:sld>
 </file>
 
-<file path=ppt/slides/slide5.xml><?xml version="1.0" encoding="utf-8"?>
+<file path=ppt/slides/slide7.xml><?xml version="1.0" encoding="utf-8"?>
 <p:sld xmlns:a="http://schemas.openxmlformats.org/drawingml/2006/main" xmlns:r="http://schemas.openxmlformats.org/officeDocument/2006/relationships" xmlns:p="http://schemas.openxmlformats.org/presentationml/2006/main">
   <p:cSld>
     <p:spTree>
@@ -11123,7 +11931,7 @@
 </p:sld>
 </file>
 
-<file path=ppt/slides/slide6.xml><?xml version="1.0" encoding="utf-8"?>
+<file path=ppt/slides/slide8.xml><?xml version="1.0" encoding="utf-8"?>
 <p:sld xmlns:a="http://schemas.openxmlformats.org/drawingml/2006/main" xmlns:r="http://schemas.openxmlformats.org/officeDocument/2006/relationships" xmlns:p="http://schemas.openxmlformats.org/presentationml/2006/main">
   <p:cSld>
     <p:spTree>
@@ -11186,8 +11994,14 @@
               </a:rPr>
             </a:br>
             <a:r>
+              <a:rPr lang="en-US" sz="1600" dirty="0">
+                <a:latin typeface="Garamond" panose="02020404030301010803" pitchFamily="18" charset="0"/>
+              </a:rPr>
+              <a:t>T</a:t>
+            </a:r>
+            <a:r>
               <a:rPr lang="en-US" sz="1600" dirty="0"/>
-              <a:t>Comparing both charts, the slices are nearly identical, indicating that </a:t>
+              <a:t>he slices are nearly identical, indicating that </a:t>
             </a:r>
             <a:r>
               <a:rPr lang="en-US" sz="1600" b="1" dirty="0"/>
@@ -11195,15 +12009,12 @@
             </a:r>
             <a:r>
               <a:rPr lang="en-US" sz="1600" dirty="0"/>
-              <a:t> for H1N1 vaccination. Men and women made decisions at similar rates, allowing us to focus on </a:t>
+              <a:t> for H1N1 vaccination allowing us to focus on </a:t>
             </a:r>
             <a:r>
               <a:rPr lang="en-US" sz="1600" b="1" dirty="0"/>
               <a:t>behavioral drivers</a:t>
             </a:r>
-            <a:br>
-              <a:rPr lang="en-US" sz="1600" dirty="0"/>
-            </a:br>
             <a:br>
               <a:rPr lang="en-US" sz="1600" b="1" dirty="0">
                 <a:latin typeface="Garamond" panose="02020404030301010803" pitchFamily="18" charset="0"/>
@@ -11259,7 +12070,7 @@
 </p:sld>
 </file>
 
-<file path=ppt/slides/slide7.xml><?xml version="1.0" encoding="utf-8"?>
+<file path=ppt/slides/slide9.xml><?xml version="1.0" encoding="utf-8"?>
 <p:sld xmlns:a="http://schemas.openxmlformats.org/drawingml/2006/main" xmlns:r="http://schemas.openxmlformats.org/officeDocument/2006/relationships" xmlns:p="http://schemas.openxmlformats.org/presentationml/2006/main">
   <p:cSld>
     <p:spTree>
@@ -11317,7 +12128,7 @@
               </a:rPr>
             </a:br>
             <a:r>
-              <a:rPr lang="en-US" sz="2700" dirty="0">
+              <a:rPr lang="en-US" sz="2400" dirty="0">
                 <a:latin typeface="Garamond" panose="02020404030301010803" pitchFamily="18" charset="0"/>
               </a:rPr>
               <a:t>From Data Processing to Socioeconomic Insight</a:t>
@@ -11545,440 +12356,6 @@
     <p:extLst>
       <p:ext uri="{BB962C8B-B14F-4D97-AF65-F5344CB8AC3E}">
         <p14:creationId xmlns:p14="http://schemas.microsoft.com/office/powerpoint/2010/main" val="699808162"/>
-      </p:ext>
-    </p:extLst>
-  </p:cSld>
-  <p:clrMapOvr>
-    <a:masterClrMapping/>
-  </p:clrMapOvr>
-</p:sld>
-</file>
-
-<file path=ppt/slides/slide8.xml><?xml version="1.0" encoding="utf-8"?>
-<p:sld xmlns:a="http://schemas.openxmlformats.org/drawingml/2006/main" xmlns:r="http://schemas.openxmlformats.org/officeDocument/2006/relationships" xmlns:p="http://schemas.openxmlformats.org/presentationml/2006/main">
-  <p:cSld>
-    <p:spTree>
-      <p:nvGrpSpPr>
-        <p:cNvPr id="1" name="">
-          <a:extLst>
-            <a:ext uri="{FF2B5EF4-FFF2-40B4-BE49-F238E27FC236}">
-              <a16:creationId xmlns:a16="http://schemas.microsoft.com/office/drawing/2014/main" id="{E7487181-9552-270E-C500-0B6E4EED9D15}"/>
-            </a:ext>
-          </a:extLst>
-        </p:cNvPr>
-        <p:cNvGrpSpPr/>
-        <p:nvPr/>
-      </p:nvGrpSpPr>
-      <p:grpSpPr>
-        <a:xfrm>
-          <a:off x="0" y="0"/>
-          <a:ext cx="0" cy="0"/>
-          <a:chOff x="0" y="0"/>
-          <a:chExt cx="0" cy="0"/>
-        </a:xfrm>
-      </p:grpSpPr>
-      <p:sp>
-        <p:nvSpPr>
-          <p:cNvPr id="2" name="Title 1">
-            <a:extLst>
-              <a:ext uri="{FF2B5EF4-FFF2-40B4-BE49-F238E27FC236}">
-                <a16:creationId xmlns:a16="http://schemas.microsoft.com/office/drawing/2014/main" id="{7DBF6588-C9F8-B5D3-086F-6EA1ADC3336F}"/>
-              </a:ext>
-            </a:extLst>
-          </p:cNvPr>
-          <p:cNvSpPr>
-            <a:spLocks noGrp="1"/>
-          </p:cNvSpPr>
-          <p:nvPr>
-            <p:ph type="title"/>
-          </p:nvPr>
-        </p:nvSpPr>
-        <p:spPr/>
-        <p:txBody>
-          <a:bodyPr>
-            <a:normAutofit/>
-          </a:bodyPr>
-          <a:lstStyle/>
-          <a:p>
-            <a:r>
-              <a:rPr lang="en-US" sz="3600" b="1" dirty="0">
-                <a:latin typeface="Garamond" panose="02020404030301010803" pitchFamily="18" charset="0"/>
-              </a:rPr>
-              <a:t>Escaping the Accuracy Trap</a:t>
-            </a:r>
-            <a:br>
-              <a:rPr lang="en-US" sz="3600" b="1" dirty="0">
-                <a:latin typeface="Garamond" panose="02020404030301010803" pitchFamily="18" charset="0"/>
-              </a:rPr>
-            </a:br>
-            <a:r>
-              <a:rPr lang="en-US" sz="2700" dirty="0">
-                <a:latin typeface="Garamond" panose="02020404030301010803" pitchFamily="18" charset="0"/>
-              </a:rPr>
-              <a:t>Prioritizing Recall Over Accuracy</a:t>
-            </a:r>
-          </a:p>
-        </p:txBody>
-      </p:sp>
-      <p:sp>
-        <p:nvSpPr>
-          <p:cNvPr id="3" name="Content Placeholder 2">
-            <a:extLst>
-              <a:ext uri="{FF2B5EF4-FFF2-40B4-BE49-F238E27FC236}">
-                <a16:creationId xmlns:a16="http://schemas.microsoft.com/office/drawing/2014/main" id="{F2E71823-E482-82DF-AD19-6AFE5CB1B331}"/>
-              </a:ext>
-            </a:extLst>
-          </p:cNvPr>
-          <p:cNvSpPr>
-            <a:spLocks noGrp="1"/>
-          </p:cNvSpPr>
-          <p:nvPr>
-            <p:ph idx="1"/>
-          </p:nvPr>
-        </p:nvSpPr>
-        <p:spPr/>
-        <p:txBody>
-          <a:bodyPr>
-            <a:normAutofit fontScale="47500" lnSpcReduction="20000"/>
-          </a:bodyPr>
-          <a:lstStyle/>
-          <a:p>
-            <a:pPr marL="0" indent="0">
-              <a:buNone/>
-            </a:pPr>
-            <a:r>
-              <a:rPr lang="en-US" sz="2500" b="1" dirty="0">
-                <a:latin typeface="Garamond" panose="02020404030301010803" pitchFamily="18" charset="0"/>
-              </a:rPr>
-              <a:t>The Core Discovery</a:t>
-            </a:r>
-          </a:p>
-          <a:p>
-            <a:pPr>
-              <a:buFont typeface="Wingdings" panose="05000000000000000000" pitchFamily="2" charset="2"/>
-              <a:buChar char="q"/>
-            </a:pPr>
-            <a:r>
-              <a:rPr lang="en-US" dirty="0">
-                <a:latin typeface="Garamond" panose="02020404030301010803" pitchFamily="18" charset="0"/>
-              </a:rPr>
-              <a:t>Hygiene ≠ vaccination </a:t>
-            </a:r>
-          </a:p>
-          <a:p>
-            <a:pPr>
-              <a:buFont typeface="Wingdings" panose="05000000000000000000" pitchFamily="2" charset="2"/>
-              <a:buChar char="q"/>
-            </a:pPr>
-            <a:r>
-              <a:rPr lang="en-US" b="1" dirty="0">
-                <a:latin typeface="Garamond" panose="02020404030301010803" pitchFamily="18" charset="0"/>
-              </a:rPr>
-              <a:t>Trust in effectiveness = key driver</a:t>
-            </a:r>
-            <a:r>
-              <a:rPr lang="en-US" dirty="0">
-                <a:latin typeface="Garamond" panose="02020404030301010803" pitchFamily="18" charset="0"/>
-              </a:rPr>
-              <a:t> </a:t>
-            </a:r>
-            <a:br>
-              <a:rPr lang="en-US" dirty="0">
-                <a:latin typeface="Garamond" panose="02020404030301010803" pitchFamily="18" charset="0"/>
-              </a:rPr>
-            </a:br>
-            <a:endParaRPr lang="en-US" dirty="0">
-              <a:latin typeface="Garamond" panose="02020404030301010803" pitchFamily="18" charset="0"/>
-            </a:endParaRPr>
-          </a:p>
-          <a:p>
-            <a:pPr marL="0" indent="0">
-              <a:buNone/>
-            </a:pPr>
-            <a:r>
-              <a:rPr lang="en-US" sz="2500" b="1" dirty="0">
-                <a:latin typeface="Garamond" panose="02020404030301010803" pitchFamily="18" charset="0"/>
-              </a:rPr>
-              <a:t>The Problem with Accuracy</a:t>
-            </a:r>
-          </a:p>
-          <a:p>
-            <a:pPr>
-              <a:buFont typeface="Wingdings" panose="05000000000000000000" pitchFamily="2" charset="2"/>
-              <a:buChar char="q"/>
-            </a:pPr>
-            <a:r>
-              <a:rPr lang="en-US" dirty="0">
-                <a:latin typeface="Garamond" panose="02020404030301010803" pitchFamily="18" charset="0"/>
-              </a:rPr>
-              <a:t>79% accuracy possible by predicting “No” </a:t>
-            </a:r>
-          </a:p>
-          <a:p>
-            <a:pPr>
-              <a:buFont typeface="Wingdings" panose="05000000000000000000" pitchFamily="2" charset="2"/>
-              <a:buChar char="q"/>
-            </a:pPr>
-            <a:r>
-              <a:rPr lang="en-US" dirty="0">
-                <a:latin typeface="Garamond" panose="02020404030301010803" pitchFamily="18" charset="0"/>
-              </a:rPr>
-              <a:t>High accuracy can still fail in practice </a:t>
-            </a:r>
-            <a:br>
-              <a:rPr lang="en-US" dirty="0">
-                <a:latin typeface="Garamond" panose="02020404030301010803" pitchFamily="18" charset="0"/>
-              </a:rPr>
-            </a:br>
-            <a:endParaRPr lang="en-US" dirty="0">
-              <a:latin typeface="Garamond" panose="02020404030301010803" pitchFamily="18" charset="0"/>
-            </a:endParaRPr>
-          </a:p>
-          <a:p>
-            <a:pPr marL="0" indent="0">
-              <a:buNone/>
-            </a:pPr>
-            <a:r>
-              <a:rPr lang="en-US" sz="2900" b="1" dirty="0">
-                <a:latin typeface="Garamond" panose="02020404030301010803" pitchFamily="18" charset="0"/>
-              </a:rPr>
-              <a:t>The Strategic Pivot</a:t>
-            </a:r>
-          </a:p>
-          <a:p>
-            <a:pPr>
-              <a:buFont typeface="Wingdings" panose="05000000000000000000" pitchFamily="2" charset="2"/>
-              <a:buChar char="q"/>
-            </a:pPr>
-            <a:r>
-              <a:rPr lang="en-US" dirty="0">
-                <a:latin typeface="Garamond" panose="02020404030301010803" pitchFamily="18" charset="0"/>
-              </a:rPr>
-              <a:t>Focus on </a:t>
-            </a:r>
-            <a:r>
-              <a:rPr lang="en-US" b="1" dirty="0">
-                <a:latin typeface="Garamond" panose="02020404030301010803" pitchFamily="18" charset="0"/>
-              </a:rPr>
-              <a:t>Recall (find potential vaccinees)</a:t>
-            </a:r>
-            <a:r>
-              <a:rPr lang="en-US" dirty="0">
-                <a:latin typeface="Garamond" panose="02020404030301010803" pitchFamily="18" charset="0"/>
-              </a:rPr>
-              <a:t> </a:t>
-            </a:r>
-          </a:p>
-          <a:p>
-            <a:pPr>
-              <a:buFont typeface="Wingdings" panose="05000000000000000000" pitchFamily="2" charset="2"/>
-              <a:buChar char="q"/>
-            </a:pPr>
-            <a:r>
-              <a:rPr lang="en-US" dirty="0">
-                <a:latin typeface="Garamond" panose="02020404030301010803" pitchFamily="18" charset="0"/>
-              </a:rPr>
-              <a:t>Minimize missed opportunities </a:t>
-            </a:r>
-            <a:br>
-              <a:rPr lang="en-US" dirty="0">
-                <a:latin typeface="Garamond" panose="02020404030301010803" pitchFamily="18" charset="0"/>
-              </a:rPr>
-            </a:br>
-            <a:endParaRPr lang="en-US" dirty="0">
-              <a:latin typeface="Garamond" panose="02020404030301010803" pitchFamily="18" charset="0"/>
-            </a:endParaRPr>
-          </a:p>
-          <a:p>
-            <a:pPr marL="0" indent="0">
-              <a:buNone/>
-            </a:pPr>
-            <a:r>
-              <a:rPr lang="en-US" b="1" dirty="0">
-                <a:latin typeface="Garamond" panose="02020404030301010803" pitchFamily="18" charset="0"/>
-              </a:rPr>
-              <a:t>Key Insight</a:t>
-            </a:r>
-          </a:p>
-          <a:p>
-            <a:pPr>
-              <a:buFont typeface="Wingdings" panose="05000000000000000000" pitchFamily="2" charset="2"/>
-              <a:buChar char="q"/>
-            </a:pPr>
-            <a:r>
-              <a:rPr lang="en-US" b="1" dirty="0">
-                <a:latin typeface="Garamond" panose="02020404030301010803" pitchFamily="18" charset="0"/>
-              </a:rPr>
-              <a:t>Better to reach more than to miss the willing</a:t>
-            </a:r>
-            <a:endParaRPr lang="en-US" dirty="0">
-              <a:latin typeface="Garamond" panose="02020404030301010803" pitchFamily="18" charset="0"/>
-            </a:endParaRPr>
-          </a:p>
-          <a:p>
-            <a:endParaRPr lang="en-US" dirty="0">
-              <a:latin typeface="Garamond" panose="02020404030301010803" pitchFamily="18" charset="0"/>
-            </a:endParaRPr>
-          </a:p>
-        </p:txBody>
-      </p:sp>
-    </p:spTree>
-    <p:extLst>
-      <p:ext uri="{BB962C8B-B14F-4D97-AF65-F5344CB8AC3E}">
-        <p14:creationId xmlns:p14="http://schemas.microsoft.com/office/powerpoint/2010/main" val="1588391361"/>
-      </p:ext>
-    </p:extLst>
-  </p:cSld>
-  <p:clrMapOvr>
-    <a:masterClrMapping/>
-  </p:clrMapOvr>
-</p:sld>
-</file>
-
-<file path=ppt/slides/slide9.xml><?xml version="1.0" encoding="utf-8"?>
-<p:sld xmlns:a="http://schemas.openxmlformats.org/drawingml/2006/main" xmlns:r="http://schemas.openxmlformats.org/officeDocument/2006/relationships" xmlns:p="http://schemas.openxmlformats.org/presentationml/2006/main">
-  <p:cSld>
-    <p:spTree>
-      <p:nvGrpSpPr>
-        <p:cNvPr id="1" name="">
-          <a:extLst>
-            <a:ext uri="{FF2B5EF4-FFF2-40B4-BE49-F238E27FC236}">
-              <a16:creationId xmlns:a16="http://schemas.microsoft.com/office/drawing/2014/main" id="{F389E7E5-F9F3-DC55-786F-24ED30F1E4F0}"/>
-            </a:ext>
-          </a:extLst>
-        </p:cNvPr>
-        <p:cNvGrpSpPr/>
-        <p:nvPr/>
-      </p:nvGrpSpPr>
-      <p:grpSpPr>
-        <a:xfrm>
-          <a:off x="0" y="0"/>
-          <a:ext cx="0" cy="0"/>
-          <a:chOff x="0" y="0"/>
-          <a:chExt cx="0" cy="0"/>
-        </a:xfrm>
-      </p:grpSpPr>
-      <p:sp>
-        <p:nvSpPr>
-          <p:cNvPr id="2" name="Title 1">
-            <a:extLst>
-              <a:ext uri="{FF2B5EF4-FFF2-40B4-BE49-F238E27FC236}">
-                <a16:creationId xmlns:a16="http://schemas.microsoft.com/office/drawing/2014/main" id="{B31E2171-BC38-1EF7-567C-C7D282A7A577}"/>
-              </a:ext>
-            </a:extLst>
-          </p:cNvPr>
-          <p:cNvSpPr>
-            <a:spLocks noGrp="1"/>
-          </p:cNvSpPr>
-          <p:nvPr>
-            <p:ph type="title"/>
-          </p:nvPr>
-        </p:nvSpPr>
-        <p:spPr>
-          <a:xfrm>
-            <a:off x="555585" y="1352744"/>
-            <a:ext cx="8027043" cy="1143000"/>
-          </a:xfrm>
-        </p:spPr>
-        <p:txBody>
-          <a:bodyPr>
-            <a:noAutofit/>
-          </a:bodyPr>
-          <a:lstStyle/>
-          <a:p>
-            <a:r>
-              <a:rPr lang="en-US" sz="2800" b="1" dirty="0">
-                <a:latin typeface="Garamond" panose="02020404030301010803" pitchFamily="18" charset="0"/>
-              </a:rPr>
-              <a:t>Perception of Risk as a Vaccination Drive</a:t>
-            </a:r>
-            <a:br>
-              <a:rPr lang="en-US" sz="2800" b="1" dirty="0">
-                <a:latin typeface="Garamond" panose="02020404030301010803" pitchFamily="18" charset="0"/>
-              </a:rPr>
-            </a:br>
-            <a:br>
-              <a:rPr lang="en-US" sz="2800" b="1" dirty="0">
-                <a:latin typeface="Garamond" panose="02020404030301010803" pitchFamily="18" charset="0"/>
-              </a:rPr>
-            </a:br>
-            <a:r>
-              <a:rPr lang="en-US" sz="1600" dirty="0"/>
-              <a:t>The upward trend in the blue segments shows that while few who felt </a:t>
-            </a:r>
-            <a:r>
-              <a:rPr lang="en-US" sz="1600" b="1" dirty="0"/>
-              <a:t>Low Risk </a:t>
-            </a:r>
-            <a:r>
-              <a:rPr lang="en-US" sz="1600" dirty="0"/>
-              <a:t>got vaccinated, nearly half of those perceiving </a:t>
-            </a:r>
-            <a:r>
-              <a:rPr lang="en-US" sz="1600" b="1" dirty="0"/>
-              <a:t>Highest Risk </a:t>
-            </a:r>
-            <a:r>
-              <a:rPr lang="en-US" sz="1600" dirty="0"/>
-              <a:t>took action. This highlights the importance of </a:t>
-            </a:r>
-            <a:r>
-              <a:rPr lang="en-US" sz="1600" b="1" dirty="0"/>
-              <a:t>public health messaging</a:t>
-            </a:r>
-            <a:r>
-              <a:rPr lang="en-US" sz="1600" dirty="0"/>
-              <a:t> that accurately communicates personal risk.</a:t>
-            </a:r>
-            <a:br>
-              <a:rPr lang="en-US" sz="1600" dirty="0"/>
-            </a:br>
-            <a:br>
-              <a:rPr lang="en-US" sz="3600" b="1" dirty="0">
-                <a:latin typeface="Garamond" panose="02020404030301010803" pitchFamily="18" charset="0"/>
-                <a:cs typeface="Archivo" pitchFamily="2" charset="0"/>
-              </a:rPr>
-            </a:br>
-            <a:endParaRPr lang="en-US" sz="2400" dirty="0">
-              <a:latin typeface="Garamond" panose="02020404030301010803" pitchFamily="18" charset="0"/>
-              <a:cs typeface="Archivo" pitchFamily="2" charset="0"/>
-            </a:endParaRPr>
-          </a:p>
-        </p:txBody>
-      </p:sp>
-      <p:pic>
-        <p:nvPicPr>
-          <p:cNvPr id="6" name="Content Placeholder 5">
-            <a:extLst>
-              <a:ext uri="{FF2B5EF4-FFF2-40B4-BE49-F238E27FC236}">
-                <a16:creationId xmlns:a16="http://schemas.microsoft.com/office/drawing/2014/main" id="{5B6C727D-26EA-7629-EC39-B85A9661A5A1}"/>
-              </a:ext>
-            </a:extLst>
-          </p:cNvPr>
-          <p:cNvPicPr>
-            <a:picLocks noGrp="1" noChangeAspect="1"/>
-          </p:cNvPicPr>
-          <p:nvPr>
-            <p:ph idx="1"/>
-          </p:nvPr>
-        </p:nvPicPr>
-        <p:blipFill>
-          <a:blip r:embed="rId3"/>
-          <a:stretch>
-            <a:fillRect/>
-          </a:stretch>
-        </p:blipFill>
-        <p:spPr>
-          <a:xfrm>
-            <a:off x="1039686" y="2495744"/>
-            <a:ext cx="7058839" cy="3339296"/>
-          </a:xfrm>
-        </p:spPr>
-      </p:pic>
-    </p:spTree>
-    <p:extLst>
-      <p:ext uri="{BB962C8B-B14F-4D97-AF65-F5344CB8AC3E}">
-        <p14:creationId xmlns:p14="http://schemas.microsoft.com/office/powerpoint/2010/main" val="3468541483"/>
       </p:ext>
     </p:extLst>
   </p:cSld>

</xml_diff>